<commit_message>
feat(slides): Tai thiet ke toan bo Slide Tin hoc Lop 5 & Lop 7 Tuan 04 voi tranh AI 3D cao cap va cap nhat Skill tao slide
</commit_message>
<xml_diff>
--- a/KHBD_Tin_học/Lớp_5/Tuần_04/Slide_Tin_hoc_Lop_5_Bai03_04.pptx
+++ b/KHBD_Tin_học/Lớp_5/Tuần_04/Slide_Tin_hoc_Lop_5_Bai03_04.pptx
@@ -3493,7 +3493,7 @@
         <p:spPr>
           <a:xfrm>
             <a:off x="1097280" y="1463040"/>
-            <a:ext cx="9994392" cy="182879"/>
+            <a:ext cx="9994392" cy="228600"/>
           </a:xfrm>
           <a:prstGeom prst="roundRect">
             <a:avLst/>
@@ -4367,7 +4367,7 @@
               </a:defRPr>
             </a:pPr>
             <a:r>
-              <a:t>Tình huống: Chuẩn bị hành lý cho kì nghỉ hè</a:t>
+              <a:t>Tình huống: Chuẩn bị hành lý đi nghỉ hè</a:t>
             </a:r>
           </a:p>
         </p:txBody>
@@ -4381,7 +4381,7 @@
         <p:spPr>
           <a:xfrm>
             <a:off x="365760" y="1645920"/>
-            <a:ext cx="3566160" cy="3977639"/>
+            <a:ext cx="11247120" cy="2971800"/>
           </a:xfrm>
           <a:prstGeom prst="roundRect">
             <a:avLst/>
@@ -4417,88 +4417,9 @@
           </a:p>
         </p:txBody>
       </p:sp>
-      <p:sp>
-        <p:nvSpPr>
-          <p:cNvPr id="7" name="Rounded Rectangle 6"/>
-          <p:cNvSpPr/>
-          <p:nvPr/>
-        </p:nvSpPr>
-        <p:spPr>
-          <a:xfrm>
-            <a:off x="365760" y="1645920"/>
-            <a:ext cx="3566160" cy="411479"/>
-          </a:xfrm>
-          <a:prstGeom prst="roundRect">
-            <a:avLst/>
-          </a:prstGeom>
-          <a:solidFill>
-            <a:srgbClr val="BE185D"/>
-          </a:solidFill>
-          <a:ln>
-            <a:noFill/>
-          </a:ln>
-        </p:spPr>
-        <p:style>
-          <a:lnRef idx="1">
-            <a:schemeClr val="accent1"/>
-          </a:lnRef>
-          <a:fillRef idx="3">
-            <a:schemeClr val="accent1"/>
-          </a:fillRef>
-          <a:effectRef idx="2">
-            <a:schemeClr val="accent1"/>
-          </a:effectRef>
-          <a:fontRef idx="minor">
-            <a:schemeClr val="lt1"/>
-          </a:fontRef>
-        </p:style>
-        <p:txBody>
-          <a:bodyPr rtlCol="0" anchor="ctr"/>
-          <a:lstStyle/>
-          <a:p>
-            <a:pPr algn="ctr"/>
-          </a:p>
-        </p:txBody>
-      </p:sp>
-      <p:sp>
-        <p:nvSpPr>
-          <p:cNvPr id="8" name="TextBox 7"/>
-          <p:cNvSpPr txBox="1"/>
-          <p:nvPr/>
-        </p:nvSpPr>
-        <p:spPr>
-          <a:xfrm>
-            <a:off x="365760" y="1691640"/>
-            <a:ext cx="3566160" cy="365759"/>
-          </a:xfrm>
-          <a:prstGeom prst="rect">
-            <a:avLst/>
-          </a:prstGeom>
-          <a:noFill/>
-        </p:spPr>
-        <p:txBody>
-          <a:bodyPr wrap="square" lIns="73152" rIns="73152" tIns="54864" bIns="54864">
-            <a:spAutoFit/>
-          </a:bodyPr>
-          <a:lstStyle/>
-          <a:p>
-            <a:pPr algn="ctr">
-              <a:defRPr sz="1400" b="1">
-                <a:solidFill>
-                  <a:srgbClr val="FFFFFF"/>
-                </a:solidFill>
-                <a:latin typeface="Arial"/>
-              </a:defRPr>
-            </a:pPr>
-            <a:r>
-              <a:t>1. An đi Nha Trang</a:t>
-            </a:r>
-          </a:p>
-        </p:txBody>
-      </p:sp>
       <p:pic>
         <p:nvPicPr>
-          <p:cNvPr id="9" name="Picture 8" descr="sgk_lop5_bai3_khoi_dong.png"/>
+          <p:cNvPr id="7" name="Picture 6" descr="ai_lop5_bai3_travel.jpg"/>
           <p:cNvPicPr>
             <a:picLocks noChangeAspect="1"/>
           </p:cNvPicPr>
@@ -4512,14 +4433,102 @@
         </p:blipFill>
         <p:spPr>
           <a:xfrm>
-            <a:off x="502920" y="2148840"/>
-            <a:ext cx="3291840" cy="2103120"/>
+            <a:off x="457200" y="1691640"/>
+            <a:ext cx="11064240" cy="2880360"/>
           </a:xfrm>
           <a:prstGeom prst="rect">
             <a:avLst/>
           </a:prstGeom>
         </p:spPr>
       </p:pic>
+      <p:sp>
+        <p:nvSpPr>
+          <p:cNvPr id="8" name="Rounded Rectangle 7"/>
+          <p:cNvSpPr/>
+          <p:nvPr/>
+        </p:nvSpPr>
+        <p:spPr>
+          <a:xfrm>
+            <a:off x="365760" y="4709160"/>
+            <a:ext cx="11247120" cy="960119"/>
+          </a:xfrm>
+          <a:prstGeom prst="roundRect">
+            <a:avLst/>
+          </a:prstGeom>
+          <a:solidFill>
+            <a:srgbClr val="FFFFFF"/>
+          </a:solidFill>
+          <a:ln w="19050">
+            <a:solidFill>
+              <a:srgbClr val="BE185D"/>
+            </a:solidFill>
+          </a:ln>
+        </p:spPr>
+        <p:style>
+          <a:lnRef idx="1">
+            <a:schemeClr val="accent1"/>
+          </a:lnRef>
+          <a:fillRef idx="3">
+            <a:schemeClr val="accent1"/>
+          </a:fillRef>
+          <a:effectRef idx="2">
+            <a:schemeClr val="accent1"/>
+          </a:effectRef>
+          <a:fontRef idx="minor">
+            <a:schemeClr val="lt1"/>
+          </a:fontRef>
+        </p:style>
+        <p:txBody>
+          <a:bodyPr rtlCol="0" anchor="ctr"/>
+          <a:lstStyle/>
+          <a:p>
+            <a:pPr algn="ctr"/>
+          </a:p>
+        </p:txBody>
+      </p:sp>
+      <p:sp>
+        <p:nvSpPr>
+          <p:cNvPr id="9" name="Rounded Rectangle 8"/>
+          <p:cNvSpPr/>
+          <p:nvPr/>
+        </p:nvSpPr>
+        <p:spPr>
+          <a:xfrm>
+            <a:off x="365760" y="4709160"/>
+            <a:ext cx="182880" cy="960119"/>
+          </a:xfrm>
+          <a:prstGeom prst="roundRect">
+            <a:avLst/>
+          </a:prstGeom>
+          <a:solidFill>
+            <a:srgbClr val="BE185D"/>
+          </a:solidFill>
+          <a:ln>
+            <a:noFill/>
+          </a:ln>
+        </p:spPr>
+        <p:style>
+          <a:lnRef idx="1">
+            <a:schemeClr val="accent1"/>
+          </a:lnRef>
+          <a:fillRef idx="3">
+            <a:schemeClr val="accent1"/>
+          </a:fillRef>
+          <a:effectRef idx="2">
+            <a:schemeClr val="accent1"/>
+          </a:effectRef>
+          <a:fontRef idx="minor">
+            <a:schemeClr val="lt1"/>
+          </a:fontRef>
+        </p:style>
+        <p:txBody>
+          <a:bodyPr rtlCol="0" anchor="ctr"/>
+          <a:lstStyle/>
+          <a:p>
+            <a:pPr algn="ctr"/>
+          </a:p>
+        </p:txBody>
+      </p:sp>
       <p:sp>
         <p:nvSpPr>
           <p:cNvPr id="10" name="TextBox 9"/>
@@ -4528,8 +4537,8 @@
         </p:nvSpPr>
         <p:spPr>
           <a:xfrm>
-            <a:off x="502920" y="4343400"/>
-            <a:ext cx="3291840" cy="1188719"/>
+            <a:off x="685800" y="4800600"/>
+            <a:ext cx="10607040" cy="777239"/>
           </a:xfrm>
           <a:prstGeom prst="rect">
             <a:avLst/>
@@ -4542,8 +4551,8 @@
           </a:bodyPr>
           <a:lstStyle/>
           <a:p>
-            <a:pPr algn="ctr">
-              <a:defRPr sz="1300" b="0">
+            <a:pPr algn="l">
+              <a:defRPr sz="1500" b="1">
                 <a:solidFill>
                   <a:srgbClr val="0F172A"/>
                 </a:solidFill>
@@ -4551,375 +4560,11 @@
               </a:defRPr>
             </a:pPr>
             <a:r>
-              <a:t>Nha Trang là thành phố biển, quanh năm nắng ấm. Cần đồ bơi, kem chống nắng...</a:t>
-            </a:r>
-          </a:p>
-        </p:txBody>
-      </p:sp>
-      <p:sp>
-        <p:nvSpPr>
-          <p:cNvPr id="11" name="Rounded Rectangle 10"/>
-          <p:cNvSpPr/>
-          <p:nvPr/>
-        </p:nvSpPr>
-        <p:spPr>
-          <a:xfrm>
-            <a:off x="4206240" y="1645920"/>
-            <a:ext cx="3566160" cy="3977639"/>
-          </a:xfrm>
-          <a:prstGeom prst="roundRect">
-            <a:avLst/>
-          </a:prstGeom>
-          <a:solidFill>
-            <a:srgbClr val="FFFFFF"/>
-          </a:solidFill>
-          <a:ln w="19050">
-            <a:solidFill>
-              <a:srgbClr val="EC4899"/>
-            </a:solidFill>
-          </a:ln>
-        </p:spPr>
-        <p:style>
-          <a:lnRef idx="1">
-            <a:schemeClr val="accent1"/>
-          </a:lnRef>
-          <a:fillRef idx="3">
-            <a:schemeClr val="accent1"/>
-          </a:fillRef>
-          <a:effectRef idx="2">
-            <a:schemeClr val="accent1"/>
-          </a:effectRef>
-          <a:fontRef idx="minor">
-            <a:schemeClr val="lt1"/>
-          </a:fontRef>
-        </p:style>
-        <p:txBody>
-          <a:bodyPr rtlCol="0" anchor="ctr"/>
-          <a:lstStyle/>
-          <a:p>
-            <a:pPr algn="ctr"/>
-          </a:p>
-        </p:txBody>
-      </p:sp>
-      <p:sp>
-        <p:nvSpPr>
-          <p:cNvPr id="12" name="Rounded Rectangle 11"/>
-          <p:cNvSpPr/>
-          <p:nvPr/>
-        </p:nvSpPr>
-        <p:spPr>
-          <a:xfrm>
-            <a:off x="4206240" y="1645920"/>
-            <a:ext cx="3566160" cy="411479"/>
-          </a:xfrm>
-          <a:prstGeom prst="roundRect">
-            <a:avLst/>
-          </a:prstGeom>
-          <a:solidFill>
-            <a:srgbClr val="BE185D"/>
-          </a:solidFill>
-          <a:ln>
-            <a:noFill/>
-          </a:ln>
-        </p:spPr>
-        <p:style>
-          <a:lnRef idx="1">
-            <a:schemeClr val="accent1"/>
-          </a:lnRef>
-          <a:fillRef idx="3">
-            <a:schemeClr val="accent1"/>
-          </a:fillRef>
-          <a:effectRef idx="2">
-            <a:schemeClr val="accent1"/>
-          </a:effectRef>
-          <a:fontRef idx="minor">
-            <a:schemeClr val="lt1"/>
-          </a:fontRef>
-        </p:style>
-        <p:txBody>
-          <a:bodyPr rtlCol="0" anchor="ctr"/>
-          <a:lstStyle/>
-          <a:p>
-            <a:pPr algn="ctr"/>
-          </a:p>
-        </p:txBody>
-      </p:sp>
-      <p:sp>
-        <p:nvSpPr>
-          <p:cNvPr id="13" name="TextBox 12"/>
-          <p:cNvSpPr txBox="1"/>
-          <p:nvPr/>
-        </p:nvSpPr>
-        <p:spPr>
-          <a:xfrm>
-            <a:off x="4206240" y="1691640"/>
-            <a:ext cx="3566160" cy="365759"/>
-          </a:xfrm>
-          <a:prstGeom prst="rect">
-            <a:avLst/>
-          </a:prstGeom>
-          <a:noFill/>
-        </p:spPr>
-        <p:txBody>
-          <a:bodyPr wrap="square" lIns="73152" rIns="73152" tIns="54864" bIns="54864">
-            <a:spAutoFit/>
-          </a:bodyPr>
-          <a:lstStyle/>
-          <a:p>
-            <a:pPr algn="ctr">
-              <a:defRPr sz="1400" b="1">
-                <a:solidFill>
-                  <a:srgbClr val="FFFFFF"/>
-                </a:solidFill>
-                <a:latin typeface="Arial"/>
-              </a:defRPr>
-            </a:pPr>
-            <a:r>
-              <a:t>2. Khoa đi Đà Lạt</a:t>
-            </a:r>
-          </a:p>
-        </p:txBody>
-      </p:sp>
-      <p:pic>
-        <p:nvPicPr>
-          <p:cNvPr id="14" name="Picture 13" descr="sgk_lop5_bai3_khoi_dong.png"/>
-          <p:cNvPicPr>
-            <a:picLocks noChangeAspect="1"/>
-          </p:cNvPicPr>
-          <p:nvPr/>
-        </p:nvPicPr>
-        <p:blipFill>
-          <a:blip r:embed="rId2"/>
-          <a:stretch>
-            <a:fillRect/>
-          </a:stretch>
-        </p:blipFill>
-        <p:spPr>
-          <a:xfrm>
-            <a:off x="4343400" y="2148840"/>
-            <a:ext cx="3291840" cy="2103120"/>
-          </a:xfrm>
-          <a:prstGeom prst="rect">
-            <a:avLst/>
-          </a:prstGeom>
-        </p:spPr>
-      </p:pic>
-      <p:sp>
-        <p:nvSpPr>
-          <p:cNvPr id="15" name="TextBox 14"/>
-          <p:cNvSpPr txBox="1"/>
-          <p:nvPr/>
-        </p:nvSpPr>
-        <p:spPr>
-          <a:xfrm>
-            <a:off x="4343400" y="4343400"/>
-            <a:ext cx="3291840" cy="1188719"/>
-          </a:xfrm>
-          <a:prstGeom prst="rect">
-            <a:avLst/>
-          </a:prstGeom>
-          <a:noFill/>
-        </p:spPr>
-        <p:txBody>
-          <a:bodyPr wrap="square" lIns="73152" rIns="73152" tIns="54864" bIns="54864">
-            <a:spAutoFit/>
-          </a:bodyPr>
-          <a:lstStyle/>
-          <a:p>
-            <a:pPr algn="ctr">
-              <a:defRPr sz="1300" b="0">
-                <a:solidFill>
-                  <a:srgbClr val="0F172A"/>
-                </a:solidFill>
-                <a:latin typeface="Arial"/>
-              </a:defRPr>
-            </a:pPr>
-            <a:r>
-              <a:t>Đà Lạt nằm ở vùng cao nguyên, đêm se lạnh. Cần áo ấm, áo khoác gió...</a:t>
-            </a:r>
-          </a:p>
-        </p:txBody>
-      </p:sp>
-      <p:sp>
-        <p:nvSpPr>
-          <p:cNvPr id="16" name="Rounded Rectangle 15"/>
-          <p:cNvSpPr/>
-          <p:nvPr/>
-        </p:nvSpPr>
-        <p:spPr>
-          <a:xfrm>
-            <a:off x="8046720" y="1645920"/>
-            <a:ext cx="3566160" cy="3977639"/>
-          </a:xfrm>
-          <a:prstGeom prst="roundRect">
-            <a:avLst/>
-          </a:prstGeom>
-          <a:solidFill>
-            <a:srgbClr val="FFFFFF"/>
-          </a:solidFill>
-          <a:ln w="19050">
-            <a:solidFill>
-              <a:srgbClr val="EC4899"/>
-            </a:solidFill>
-          </a:ln>
-        </p:spPr>
-        <p:style>
-          <a:lnRef idx="1">
-            <a:schemeClr val="accent1"/>
-          </a:lnRef>
-          <a:fillRef idx="3">
-            <a:schemeClr val="accent1"/>
-          </a:fillRef>
-          <a:effectRef idx="2">
-            <a:schemeClr val="accent1"/>
-          </a:effectRef>
-          <a:fontRef idx="minor">
-            <a:schemeClr val="lt1"/>
-          </a:fontRef>
-        </p:style>
-        <p:txBody>
-          <a:bodyPr rtlCol="0" anchor="ctr"/>
-          <a:lstStyle/>
-          <a:p>
-            <a:pPr algn="ctr"/>
-          </a:p>
-        </p:txBody>
-      </p:sp>
-      <p:sp>
-        <p:nvSpPr>
-          <p:cNvPr id="17" name="Rounded Rectangle 16"/>
-          <p:cNvSpPr/>
-          <p:nvPr/>
-        </p:nvSpPr>
-        <p:spPr>
-          <a:xfrm>
-            <a:off x="8046720" y="1645920"/>
-            <a:ext cx="3566160" cy="411479"/>
-          </a:xfrm>
-          <a:prstGeom prst="roundRect">
-            <a:avLst/>
-          </a:prstGeom>
-          <a:solidFill>
-            <a:srgbClr val="BE185D"/>
-          </a:solidFill>
-          <a:ln>
-            <a:noFill/>
-          </a:ln>
-        </p:spPr>
-        <p:style>
-          <a:lnRef idx="1">
-            <a:schemeClr val="accent1"/>
-          </a:lnRef>
-          <a:fillRef idx="3">
-            <a:schemeClr val="accent1"/>
-          </a:fillRef>
-          <a:effectRef idx="2">
-            <a:schemeClr val="accent1"/>
-          </a:effectRef>
-          <a:fontRef idx="minor">
-            <a:schemeClr val="lt1"/>
-          </a:fontRef>
-        </p:style>
-        <p:txBody>
-          <a:bodyPr rtlCol="0" anchor="ctr"/>
-          <a:lstStyle/>
-          <a:p>
-            <a:pPr algn="ctr"/>
-          </a:p>
-        </p:txBody>
-      </p:sp>
-      <p:sp>
-        <p:nvSpPr>
-          <p:cNvPr id="18" name="TextBox 17"/>
-          <p:cNvSpPr txBox="1"/>
-          <p:nvPr/>
-        </p:nvSpPr>
-        <p:spPr>
-          <a:xfrm>
-            <a:off x="8046720" y="1691640"/>
-            <a:ext cx="3566160" cy="365759"/>
-          </a:xfrm>
-          <a:prstGeom prst="rect">
-            <a:avLst/>
-          </a:prstGeom>
-          <a:noFill/>
-        </p:spPr>
-        <p:txBody>
-          <a:bodyPr wrap="square" lIns="73152" rIns="73152" tIns="54864" bIns="54864">
-            <a:spAutoFit/>
-          </a:bodyPr>
-          <a:lstStyle/>
-          <a:p>
-            <a:pPr algn="ctr">
-              <a:defRPr sz="1400" b="1">
-                <a:solidFill>
-                  <a:srgbClr val="FFFFFF"/>
-                </a:solidFill>
-                <a:latin typeface="Arial"/>
-              </a:defRPr>
-            </a:pPr>
-            <a:r>
-              <a:t>3. Minh đi Úc</a:t>
-            </a:r>
-          </a:p>
-        </p:txBody>
-      </p:sp>
-      <p:pic>
-        <p:nvPicPr>
-          <p:cNvPr id="19" name="Picture 18" descr="sgk_lop5_bai3_khoi_dong.png"/>
-          <p:cNvPicPr>
-            <a:picLocks noChangeAspect="1"/>
-          </p:cNvPicPr>
-          <p:nvPr/>
-        </p:nvPicPr>
-        <p:blipFill>
-          <a:blip r:embed="rId2"/>
-          <a:stretch>
-            <a:fillRect/>
-          </a:stretch>
-        </p:blipFill>
-        <p:spPr>
-          <a:xfrm>
-            <a:off x="8183880" y="2148840"/>
-            <a:ext cx="3291840" cy="2103120"/>
-          </a:xfrm>
-          <a:prstGeom prst="rect">
-            <a:avLst/>
-          </a:prstGeom>
-        </p:spPr>
-      </p:pic>
-      <p:sp>
-        <p:nvSpPr>
-          <p:cNvPr id="20" name="TextBox 19"/>
-          <p:cNvSpPr txBox="1"/>
-          <p:nvPr/>
-        </p:nvSpPr>
-        <p:spPr>
-          <a:xfrm>
-            <a:off x="8183880" y="4343400"/>
-            <a:ext cx="3291840" cy="1188719"/>
-          </a:xfrm>
-          <a:prstGeom prst="rect">
-            <a:avLst/>
-          </a:prstGeom>
-          <a:noFill/>
-        </p:spPr>
-        <p:txBody>
-          <a:bodyPr wrap="square" lIns="73152" rIns="73152" tIns="54864" bIns="54864">
-            <a:spAutoFit/>
-          </a:bodyPr>
-          <a:lstStyle/>
-          <a:p>
-            <a:pPr algn="ctr">
-              <a:defRPr sz="1300" b="0">
-                <a:solidFill>
-                  <a:srgbClr val="0F172A"/>
-                </a:solidFill>
-                <a:latin typeface="Arial"/>
-              </a:defRPr>
-            </a:pPr>
-            <a:r>
-              <a:t>Nước Úc ở Nam bán cầu. Mùa hè Việt Nam là mùa đông ở Úc! Cần áo phao dày.</a:t>
+              <a:t>👉 An đi biển Nha Trang (nắng nóng), Khoa đi Đà Lạt (se lạnh), Minh đi Úc (mùa đông tuyết).</a:t>
+            </a:r>
+            <a:br/>
+            <a:r>
+              <a:t>Vì sao mỗi bạn phải chuẩn bị hành lý hoàn toàn khác nhau?</a:t>
             </a:r>
           </a:p>
         </p:txBody>
@@ -5062,7 +4707,7 @@
               </a:defRPr>
             </a:pPr>
             <a:r>
-              <a:t>QUY TRÌNH &amp; THAO TÁC</a:t>
+              <a:t>HOẠT ĐỘNG KHÁM PHÁ</a:t>
             </a:r>
           </a:p>
         </p:txBody>
@@ -5098,30 +4743,32 @@
               </a:defRPr>
             </a:pPr>
             <a:r>
-              <a:t>Kỹ thuật sử dụng từ khóa tìm kiếm trên Internet</a:t>
-            </a:r>
-          </a:p>
-        </p:txBody>
-      </p:sp>
-      <p:sp>
-        <p:nvSpPr>
-          <p:cNvPr id="6" name="Chevron 5"/>
+              <a:t>Kỹ thuật sử dụng Từ khóa tìm kiếm thần kỳ</a:t>
+            </a:r>
+          </a:p>
+        </p:txBody>
+      </p:sp>
+      <p:sp>
+        <p:nvSpPr>
+          <p:cNvPr id="6" name="Rounded Rectangle 5"/>
           <p:cNvSpPr/>
           <p:nvPr/>
         </p:nvSpPr>
         <p:spPr>
           <a:xfrm>
             <a:off x="365760" y="1645920"/>
-            <a:ext cx="4754880" cy="868680"/>
-          </a:xfrm>
-          <a:prstGeom prst="chevron">
+            <a:ext cx="4023360" cy="3977639"/>
+          </a:xfrm>
+          <a:prstGeom prst="roundRect">
             <a:avLst/>
           </a:prstGeom>
           <a:solidFill>
-            <a:srgbClr val="BE185D"/>
+            <a:srgbClr val="FFFFFF"/>
           </a:solidFill>
-          <a:ln>
-            <a:noFill/>
+          <a:ln w="19050">
+            <a:solidFill>
+              <a:srgbClr val="EC4899"/>
+            </a:solidFill>
           </a:ln>
         </p:spPr>
         <p:style>
@@ -5148,52 +4795,16 @@
       </p:sp>
       <p:sp>
         <p:nvSpPr>
-          <p:cNvPr id="7" name="TextBox 6"/>
-          <p:cNvSpPr txBox="1"/>
-          <p:nvPr/>
-        </p:nvSpPr>
-        <p:spPr>
-          <a:xfrm>
-            <a:off x="640080" y="1719072"/>
-            <a:ext cx="4206240" cy="731520"/>
-          </a:xfrm>
-          <a:prstGeom prst="rect">
-            <a:avLst/>
-          </a:prstGeom>
-          <a:noFill/>
-        </p:spPr>
-        <p:txBody>
-          <a:bodyPr wrap="square" lIns="73152" rIns="73152" tIns="54864" bIns="54864">
-            <a:spAutoFit/>
-          </a:bodyPr>
-          <a:lstStyle/>
-          <a:p>
-            <a:pPr algn="l">
-              <a:defRPr sz="1400" b="1">
-                <a:solidFill>
-                  <a:srgbClr val="FFFFFF"/>
-                </a:solidFill>
-                <a:latin typeface="Arial"/>
-              </a:defRPr>
-            </a:pPr>
-            <a:r>
-              <a:t>1. Chọn từ khóa ngắn gọn, chính xác (Keyword)</a:t>
-            </a:r>
-          </a:p>
-        </p:txBody>
-      </p:sp>
-      <p:sp>
-        <p:nvSpPr>
-          <p:cNvPr id="8" name="Chevron 7"/>
+          <p:cNvPr id="7" name="Rounded Rectangle 6"/>
           <p:cNvSpPr/>
           <p:nvPr/>
         </p:nvSpPr>
         <p:spPr>
           <a:xfrm>
-            <a:off x="365760" y="2624328"/>
-            <a:ext cx="4754880" cy="868680"/>
-          </a:xfrm>
-          <a:prstGeom prst="chevron">
+            <a:off x="365760" y="1645920"/>
+            <a:ext cx="164592" cy="3977639"/>
+          </a:xfrm>
+          <a:prstGeom prst="roundRect">
             <a:avLst/>
           </a:prstGeom>
           <a:solidFill>
@@ -5227,14 +4838,14 @@
       </p:sp>
       <p:sp>
         <p:nvSpPr>
-          <p:cNvPr id="9" name="TextBox 8"/>
+          <p:cNvPr id="8" name="TextBox 7"/>
           <p:cNvSpPr txBox="1"/>
           <p:nvPr/>
         </p:nvSpPr>
         <p:spPr>
           <a:xfrm>
-            <a:off x="640080" y="2697480"/>
-            <a:ext cx="4206240" cy="731519"/>
+            <a:off x="640080" y="1783080"/>
+            <a:ext cx="3611880" cy="640080"/>
           </a:xfrm>
           <a:prstGeom prst="rect">
             <a:avLst/>
@@ -5248,72 +4859,29 @@
           <a:lstStyle/>
           <a:p>
             <a:pPr algn="l">
-              <a:defRPr sz="1400" b="1">
+              <a:defRPr sz="1500" b="1">
                 <a:solidFill>
-                  <a:srgbClr val="FFFFFF"/>
+                  <a:srgbClr val="0F172A"/>
                 </a:solidFill>
                 <a:latin typeface="Arial"/>
               </a:defRPr>
             </a:pPr>
             <a:r>
-              <a:t>2. Đặt từ khóa trong dấu ngoặc kép " " để tìm chuẩn xác</a:t>
-            </a:r>
-          </a:p>
-        </p:txBody>
-      </p:sp>
-      <p:sp>
-        <p:nvSpPr>
-          <p:cNvPr id="10" name="Chevron 9"/>
-          <p:cNvSpPr/>
-          <p:nvPr/>
-        </p:nvSpPr>
-        <p:spPr>
-          <a:xfrm>
-            <a:off x="365760" y="3602736"/>
-            <a:ext cx="4754880" cy="868679"/>
-          </a:xfrm>
-          <a:prstGeom prst="chevron">
-            <a:avLst/>
-          </a:prstGeom>
-          <a:solidFill>
-            <a:srgbClr val="0D9488"/>
-          </a:solidFill>
-          <a:ln>
-            <a:noFill/>
-          </a:ln>
-        </p:spPr>
-        <p:style>
-          <a:lnRef idx="1">
-            <a:schemeClr val="accent1"/>
-          </a:lnRef>
-          <a:fillRef idx="3">
-            <a:schemeClr val="accent1"/>
-          </a:fillRef>
-          <a:effectRef idx="2">
-            <a:schemeClr val="accent1"/>
-          </a:effectRef>
-          <a:fontRef idx="minor">
-            <a:schemeClr val="lt1"/>
-          </a:fontRef>
-        </p:style>
-        <p:txBody>
-          <a:bodyPr rtlCol="0" anchor="ctr"/>
-          <a:lstStyle/>
-          <a:p>
-            <a:pPr algn="ctr"/>
-          </a:p>
-        </p:txBody>
-      </p:sp>
-      <p:sp>
-        <p:nvSpPr>
-          <p:cNvPr id="11" name="TextBox 10"/>
+              <a:t>• Chọn từ khóa ngắn gọn, chính xác</a:t>
+            </a:r>
+          </a:p>
+        </p:txBody>
+      </p:sp>
+      <p:sp>
+        <p:nvSpPr>
+          <p:cNvPr id="9" name="TextBox 8"/>
           <p:cNvSpPr txBox="1"/>
           <p:nvPr/>
         </p:nvSpPr>
         <p:spPr>
           <a:xfrm>
-            <a:off x="640080" y="3675887"/>
-            <a:ext cx="4206240" cy="731519"/>
+            <a:off x="640080" y="2468880"/>
+            <a:ext cx="3611880" cy="640080"/>
           </a:xfrm>
           <a:prstGeom prst="rect">
             <a:avLst/>
@@ -5327,72 +4895,29 @@
           <a:lstStyle/>
           <a:p>
             <a:pPr algn="l">
-              <a:defRPr sz="1400" b="1">
+              <a:defRPr sz="1500" b="1">
                 <a:solidFill>
-                  <a:srgbClr val="FFFFFF"/>
+                  <a:srgbClr val="0F172A"/>
                 </a:solidFill>
                 <a:latin typeface="Arial"/>
               </a:defRPr>
             </a:pPr>
             <a:r>
-              <a:t>3. Chọn lọc từ website tin cậy (.gov.vn, .edu.vn)</a:t>
-            </a:r>
-          </a:p>
-        </p:txBody>
-      </p:sp>
-      <p:sp>
-        <p:nvSpPr>
-          <p:cNvPr id="12" name="Chevron 11"/>
-          <p:cNvSpPr/>
-          <p:nvPr/>
-        </p:nvSpPr>
-        <p:spPr>
-          <a:xfrm>
-            <a:off x="365760" y="4581144"/>
-            <a:ext cx="4754880" cy="868680"/>
-          </a:xfrm>
-          <a:prstGeom prst="chevron">
-            <a:avLst/>
-          </a:prstGeom>
-          <a:solidFill>
-            <a:srgbClr val="D97706"/>
-          </a:solidFill>
-          <a:ln>
-            <a:noFill/>
-          </a:ln>
-        </p:spPr>
-        <p:style>
-          <a:lnRef idx="1">
-            <a:schemeClr val="accent1"/>
-          </a:lnRef>
-          <a:fillRef idx="3">
-            <a:schemeClr val="accent1"/>
-          </a:fillRef>
-          <a:effectRef idx="2">
-            <a:schemeClr val="accent1"/>
-          </a:effectRef>
-          <a:fontRef idx="minor">
-            <a:schemeClr val="lt1"/>
-          </a:fontRef>
-        </p:style>
-        <p:txBody>
-          <a:bodyPr rtlCol="0" anchor="ctr"/>
-          <a:lstStyle/>
-          <a:p>
-            <a:pPr algn="ctr"/>
-          </a:p>
-        </p:txBody>
-      </p:sp>
-      <p:sp>
-        <p:nvSpPr>
-          <p:cNvPr id="13" name="TextBox 12"/>
+              <a:t>• Đặt từ khóa trong dấu ngoặc kép " "</a:t>
+            </a:r>
+          </a:p>
+        </p:txBody>
+      </p:sp>
+      <p:sp>
+        <p:nvSpPr>
+          <p:cNvPr id="10" name="TextBox 9"/>
           <p:cNvSpPr txBox="1"/>
           <p:nvPr/>
         </p:nvSpPr>
         <p:spPr>
           <a:xfrm>
-            <a:off x="640080" y="4654296"/>
-            <a:ext cx="4206240" cy="731519"/>
+            <a:off x="640080" y="3154680"/>
+            <a:ext cx="3611880" cy="640080"/>
           </a:xfrm>
           <a:prstGeom prst="rect">
             <a:avLst/>
@@ -5406,29 +4931,65 @@
           <a:lstStyle/>
           <a:p>
             <a:pPr algn="l">
-              <a:defRPr sz="1400" b="1">
+              <a:defRPr sz="1500" b="1">
                 <a:solidFill>
-                  <a:srgbClr val="FFFFFF"/>
+                  <a:srgbClr val="0F172A"/>
                 </a:solidFill>
                 <a:latin typeface="Arial"/>
               </a:defRPr>
             </a:pPr>
             <a:r>
-              <a:t>4. Đánh giá và tổng hợp thông tin trước khi áp dụng</a:t>
-            </a:r>
-          </a:p>
-        </p:txBody>
-      </p:sp>
-      <p:sp>
-        <p:nvSpPr>
-          <p:cNvPr id="14" name="Rounded Rectangle 13"/>
+              <a:t>• Ưu tiên nguồn tin chính thống, đáng tin cậy</a:t>
+            </a:r>
+          </a:p>
+        </p:txBody>
+      </p:sp>
+      <p:sp>
+        <p:nvSpPr>
+          <p:cNvPr id="11" name="TextBox 10"/>
+          <p:cNvSpPr txBox="1"/>
+          <p:nvPr/>
+        </p:nvSpPr>
+        <p:spPr>
+          <a:xfrm>
+            <a:off x="640080" y="3840480"/>
+            <a:ext cx="3611880" cy="640080"/>
+          </a:xfrm>
+          <a:prstGeom prst="rect">
+            <a:avLst/>
+          </a:prstGeom>
+          <a:noFill/>
+        </p:spPr>
+        <p:txBody>
+          <a:bodyPr wrap="square" lIns="73152" rIns="73152" tIns="54864" bIns="54864">
+            <a:spAutoFit/>
+          </a:bodyPr>
+          <a:lstStyle/>
+          <a:p>
+            <a:pPr algn="l">
+              <a:defRPr sz="1500" b="1">
+                <a:solidFill>
+                  <a:srgbClr val="0F172A"/>
+                </a:solidFill>
+                <a:latin typeface="Arial"/>
+              </a:defRPr>
+            </a:pPr>
+            <a:r>
+              <a:t>• Giải quyết vấn đề nhanh chóng và hiệu quả</a:t>
+            </a:r>
+          </a:p>
+        </p:txBody>
+      </p:sp>
+      <p:sp>
+        <p:nvSpPr>
+          <p:cNvPr id="12" name="Rounded Rectangle 11"/>
           <p:cNvSpPr/>
           <p:nvPr/>
         </p:nvSpPr>
         <p:spPr>
           <a:xfrm>
-            <a:off x="5394960" y="1645920"/>
-            <a:ext cx="6309360" cy="3977639"/>
+            <a:off x="4663440" y="1645920"/>
+            <a:ext cx="7040880" cy="3977639"/>
           </a:xfrm>
           <a:prstGeom prst="roundRect">
             <a:avLst/>
@@ -5466,7 +5027,7 @@
       </p:sp>
       <p:pic>
         <p:nvPicPr>
-          <p:cNvPr id="15" name="Picture 14" descr="sgk_lop5_bai3_thuc_hanh_search.png"/>
+          <p:cNvPr id="13" name="Picture 12" descr="ai_lop5_bai3_search.jpg"/>
           <p:cNvPicPr>
             <a:picLocks noChangeAspect="1"/>
           </p:cNvPicPr>
@@ -5480,8 +5041,8 @@
         </p:blipFill>
         <p:spPr>
           <a:xfrm>
-            <a:off x="5486400" y="1737360"/>
-            <a:ext cx="6126480" cy="3794760"/>
+            <a:off x="4754880" y="1737360"/>
+            <a:ext cx="6858000" cy="3794760"/>
           </a:xfrm>
           <a:prstGeom prst="rect">
             <a:avLst/>
@@ -5884,7 +5445,7 @@
               </a:defRPr>
             </a:pPr>
             <a:r>
-              <a:t>HOẠT ĐỘNG KHÁM PHÁ</a:t>
+              <a:t>KHỞI ĐỘNG &amp; TÌNH HUỐNG</a:t>
             </a:r>
           </a:p>
         </p:txBody>
@@ -5920,7 +5481,7 @@
               </a:defRPr>
             </a:pPr>
             <a:r>
-              <a:t>Cấu trúc phân cấp Cây thư mục</a:t>
+              <a:t>Cây tri thức — Sơ đồ Cây thư mục kỳ diệu</a:t>
             </a:r>
           </a:p>
         </p:txBody>
@@ -5934,7 +5495,7 @@
         <p:spPr>
           <a:xfrm>
             <a:off x="365760" y="1645920"/>
-            <a:ext cx="3840480" cy="3977639"/>
+            <a:ext cx="11247120" cy="2971800"/>
           </a:xfrm>
           <a:prstGeom prst="roundRect">
             <a:avLst/>
@@ -5970,25 +5531,51 @@
           </a:p>
         </p:txBody>
       </p:sp>
-      <p:sp>
-        <p:nvSpPr>
-          <p:cNvPr id="7" name="Rounded Rectangle 6"/>
+      <p:pic>
+        <p:nvPicPr>
+          <p:cNvPr id="7" name="Picture 6" descr="ai_lop5_bai4_tree.jpg"/>
+          <p:cNvPicPr>
+            <a:picLocks noChangeAspect="1"/>
+          </p:cNvPicPr>
+          <p:nvPr/>
+        </p:nvPicPr>
+        <p:blipFill>
+          <a:blip r:embed="rId2"/>
+          <a:stretch>
+            <a:fillRect/>
+          </a:stretch>
+        </p:blipFill>
+        <p:spPr>
+          <a:xfrm>
+            <a:off x="457200" y="1691640"/>
+            <a:ext cx="11064240" cy="2880360"/>
+          </a:xfrm>
+          <a:prstGeom prst="rect">
+            <a:avLst/>
+          </a:prstGeom>
+        </p:spPr>
+      </p:pic>
+      <p:sp>
+        <p:nvSpPr>
+          <p:cNvPr id="8" name="Rounded Rectangle 7"/>
           <p:cNvSpPr/>
           <p:nvPr/>
         </p:nvSpPr>
         <p:spPr>
           <a:xfrm>
-            <a:off x="365760" y="1645920"/>
-            <a:ext cx="164592" cy="3977639"/>
+            <a:off x="365760" y="4709160"/>
+            <a:ext cx="11247120" cy="960119"/>
           </a:xfrm>
           <a:prstGeom prst="roundRect">
             <a:avLst/>
           </a:prstGeom>
           <a:solidFill>
-            <a:srgbClr val="EC4899"/>
+            <a:srgbClr val="FFFFFF"/>
           </a:solidFill>
-          <a:ln>
-            <a:noFill/>
+          <a:ln w="19050">
+            <a:solidFill>
+              <a:srgbClr val="BE185D"/>
+            </a:solidFill>
           </a:ln>
         </p:spPr>
         <p:style>
@@ -6015,14 +5602,57 @@
       </p:sp>
       <p:sp>
         <p:nvSpPr>
-          <p:cNvPr id="8" name="TextBox 7"/>
+          <p:cNvPr id="9" name="Rounded Rectangle 8"/>
+          <p:cNvSpPr/>
+          <p:nvPr/>
+        </p:nvSpPr>
+        <p:spPr>
+          <a:xfrm>
+            <a:off x="365760" y="4709160"/>
+            <a:ext cx="182880" cy="960119"/>
+          </a:xfrm>
+          <a:prstGeom prst="roundRect">
+            <a:avLst/>
+          </a:prstGeom>
+          <a:solidFill>
+            <a:srgbClr val="BE185D"/>
+          </a:solidFill>
+          <a:ln>
+            <a:noFill/>
+          </a:ln>
+        </p:spPr>
+        <p:style>
+          <a:lnRef idx="1">
+            <a:schemeClr val="accent1"/>
+          </a:lnRef>
+          <a:fillRef idx="3">
+            <a:schemeClr val="accent1"/>
+          </a:fillRef>
+          <a:effectRef idx="2">
+            <a:schemeClr val="accent1"/>
+          </a:effectRef>
+          <a:fontRef idx="minor">
+            <a:schemeClr val="lt1"/>
+          </a:fontRef>
+        </p:style>
+        <p:txBody>
+          <a:bodyPr rtlCol="0" anchor="ctr"/>
+          <a:lstStyle/>
+          <a:p>
+            <a:pPr algn="ctr"/>
+          </a:p>
+        </p:txBody>
+      </p:sp>
+      <p:sp>
+        <p:nvSpPr>
+          <p:cNvPr id="10" name="TextBox 9"/>
           <p:cNvSpPr txBox="1"/>
           <p:nvPr/>
         </p:nvSpPr>
         <p:spPr>
           <a:xfrm>
-            <a:off x="640080" y="1783080"/>
-            <a:ext cx="3429000" cy="640080"/>
+            <a:off x="685800" y="4800600"/>
+            <a:ext cx="10607040" cy="777239"/>
           </a:xfrm>
           <a:prstGeom prst="rect">
             <a:avLst/>
@@ -6044,188 +5674,11 @@
               </a:defRPr>
             </a:pPr>
             <a:r>
-              <a:t>• Ổ đĩa gốc (Root): C:, D:, E:</a:t>
-            </a:r>
-          </a:p>
-        </p:txBody>
-      </p:sp>
-      <p:sp>
-        <p:nvSpPr>
-          <p:cNvPr id="9" name="TextBox 8"/>
-          <p:cNvSpPr txBox="1"/>
-          <p:nvPr/>
-        </p:nvSpPr>
-        <p:spPr>
-          <a:xfrm>
-            <a:off x="640080" y="2468880"/>
-            <a:ext cx="3429000" cy="640080"/>
-          </a:xfrm>
-          <a:prstGeom prst="rect">
-            <a:avLst/>
-          </a:prstGeom>
-          <a:noFill/>
-        </p:spPr>
-        <p:txBody>
-          <a:bodyPr wrap="square" lIns="73152" rIns="73152" tIns="54864" bIns="54864">
-            <a:spAutoFit/>
-          </a:bodyPr>
-          <a:lstStyle/>
-          <a:p>
-            <a:pPr algn="l">
-              <a:defRPr sz="1500" b="1">
-                <a:solidFill>
-                  <a:srgbClr val="0F172A"/>
-                </a:solidFill>
-                <a:latin typeface="Arial"/>
-              </a:defRPr>
-            </a:pPr>
-            <a:r>
-              <a:t>• Thư mục mẹ (Parent folder): Chứa thư mục khác</a:t>
-            </a:r>
-          </a:p>
-        </p:txBody>
-      </p:sp>
-      <p:sp>
-        <p:nvSpPr>
-          <p:cNvPr id="10" name="TextBox 9"/>
-          <p:cNvSpPr txBox="1"/>
-          <p:nvPr/>
-        </p:nvSpPr>
-        <p:spPr>
-          <a:xfrm>
-            <a:off x="640080" y="3154680"/>
-            <a:ext cx="3429000" cy="640080"/>
-          </a:xfrm>
-          <a:prstGeom prst="rect">
-            <a:avLst/>
-          </a:prstGeom>
-          <a:noFill/>
-        </p:spPr>
-        <p:txBody>
-          <a:bodyPr wrap="square" lIns="73152" rIns="73152" tIns="54864" bIns="54864">
-            <a:spAutoFit/>
-          </a:bodyPr>
-          <a:lstStyle/>
-          <a:p>
-            <a:pPr algn="l">
-              <a:defRPr sz="1500" b="1">
-                <a:solidFill>
-                  <a:srgbClr val="0F172A"/>
-                </a:solidFill>
-                <a:latin typeface="Arial"/>
-              </a:defRPr>
-            </a:pPr>
-            <a:r>
-              <a:t>• Thư mục con (Subfolder): Nằm bên trong thư mục mẹ</a:t>
-            </a:r>
-          </a:p>
-        </p:txBody>
-      </p:sp>
-      <p:sp>
-        <p:nvSpPr>
-          <p:cNvPr id="11" name="TextBox 10"/>
-          <p:cNvSpPr txBox="1"/>
-          <p:nvPr/>
-        </p:nvSpPr>
-        <p:spPr>
-          <a:xfrm>
-            <a:off x="640080" y="3840480"/>
-            <a:ext cx="3429000" cy="640080"/>
-          </a:xfrm>
-          <a:prstGeom prst="rect">
-            <a:avLst/>
-          </a:prstGeom>
-          <a:noFill/>
-        </p:spPr>
-        <p:txBody>
-          <a:bodyPr wrap="square" lIns="73152" rIns="73152" tIns="54864" bIns="54864">
-            <a:spAutoFit/>
-          </a:bodyPr>
-          <a:lstStyle/>
-          <a:p>
-            <a:pPr algn="l">
-              <a:defRPr sz="1500" b="1">
-                <a:solidFill>
-                  <a:srgbClr val="0F172A"/>
-                </a:solidFill>
-                <a:latin typeface="Arial"/>
-              </a:defRPr>
-            </a:pPr>
-            <a:r>
-              <a:t>• Tệp tin (File): Nơi lưu trữ nội dung cụ thể</a:t>
-            </a:r>
-          </a:p>
-        </p:txBody>
-      </p:sp>
-      <p:sp>
-        <p:nvSpPr>
-          <p:cNvPr id="12" name="Rounded Rectangle 11"/>
-          <p:cNvSpPr/>
-          <p:nvPr/>
-        </p:nvSpPr>
-        <p:spPr>
-          <a:xfrm>
-            <a:off x="4480560" y="1645920"/>
-            <a:ext cx="7223760" cy="3977639"/>
-          </a:xfrm>
-          <a:prstGeom prst="roundRect">
-            <a:avLst/>
-          </a:prstGeom>
-          <a:solidFill>
-            <a:srgbClr val="FFFFFF"/>
-          </a:solidFill>
-          <a:ln w="19050">
-            <a:solidFill>
-              <a:srgbClr val="CBD5E1"/>
-            </a:solidFill>
-          </a:ln>
-        </p:spPr>
-        <p:style>
-          <a:lnRef idx="1">
-            <a:schemeClr val="accent1"/>
-          </a:lnRef>
-          <a:fillRef idx="3">
-            <a:schemeClr val="accent1"/>
-          </a:fillRef>
-          <a:effectRef idx="2">
-            <a:schemeClr val="accent1"/>
-          </a:effectRef>
-          <a:fontRef idx="minor">
-            <a:schemeClr val="lt1"/>
-          </a:fontRef>
-        </p:style>
-        <p:txBody>
-          <a:bodyPr rtlCol="0" anchor="ctr"/>
-          <a:lstStyle/>
-          <a:p>
-            <a:pPr algn="ctr"/>
-          </a:p>
-        </p:txBody>
-      </p:sp>
-      <p:pic>
-        <p:nvPicPr>
-          <p:cNvPr id="13" name="Picture 12" descr="sgk_lop5_bai4_so_do_cay_thu_muc.png"/>
-          <p:cNvPicPr>
-            <a:picLocks noChangeAspect="1"/>
-          </p:cNvPicPr>
-          <p:nvPr/>
-        </p:nvPicPr>
-        <p:blipFill>
-          <a:blip r:embed="rId2"/>
-          <a:stretch>
-            <a:fillRect/>
-          </a:stretch>
-        </p:blipFill>
-        <p:spPr>
-          <a:xfrm>
-            <a:off x="4572000" y="1737360"/>
-            <a:ext cx="7040880" cy="3794760"/>
-          </a:xfrm>
-          <a:prstGeom prst="rect">
-            <a:avLst/>
-          </a:prstGeom>
-        </p:spPr>
-      </p:pic>
+              <a:t>👉 Gốc là ổ đĩa (C:, D:), Cành lớn là Thư mục mẹ, Cành nhỏ là Thư mục con, Quả là các Tệp tin!</a:t>
+            </a:r>
+          </a:p>
+        </p:txBody>
+      </p:sp>
     </p:spTree>
   </p:cSld>
   <p:clrMapOvr>
@@ -6364,7 +5817,7 @@
               </a:defRPr>
             </a:pPr>
             <a:r>
-              <a:t>HOẠT ĐỘNG KHÁM PHÁ</a:t>
+              <a:t>KIẾN THỨC CỐT LÕI</a:t>
             </a:r>
           </a:p>
         </p:txBody>
@@ -6400,7 +5853,7 @@
               </a:defRPr>
             </a:pPr>
             <a:r>
-              <a:t>Khám phá Cây thư mục trong File Explorer</a:t>
+              <a:t>Các thành phần trong Cây thư mục</a:t>
             </a:r>
           </a:p>
         </p:txBody>
@@ -6414,7 +5867,7 @@
         <p:spPr>
           <a:xfrm>
             <a:off x="365760" y="1645920"/>
-            <a:ext cx="3840480" cy="3977639"/>
+            <a:ext cx="3566160" cy="3977639"/>
           </a:xfrm>
           <a:prstGeom prst="roundRect">
             <a:avLst/>
@@ -6424,7 +5877,7 @@
           </a:solidFill>
           <a:ln w="19050">
             <a:solidFill>
-              <a:srgbClr val="EC4899"/>
+              <a:srgbClr val="BE185D"/>
             </a:solidFill>
           </a:ln>
         </p:spPr>
@@ -6459,13 +5912,13 @@
         <p:spPr>
           <a:xfrm>
             <a:off x="365760" y="1645920"/>
-            <a:ext cx="164592" cy="3977639"/>
+            <a:ext cx="3566160" cy="457199"/>
           </a:xfrm>
           <a:prstGeom prst="roundRect">
             <a:avLst/>
           </a:prstGeom>
           <a:solidFill>
-            <a:srgbClr val="EC4899"/>
+            <a:srgbClr val="BE185D"/>
           </a:solidFill>
           <a:ln>
             <a:noFill/>
@@ -6501,8 +5954,8 @@
         </p:nvSpPr>
         <p:spPr>
           <a:xfrm>
-            <a:off x="640080" y="1783080"/>
-            <a:ext cx="3429000" cy="640080"/>
+            <a:off x="365760" y="1691640"/>
+            <a:ext cx="3566160" cy="411480"/>
           </a:xfrm>
           <a:prstGeom prst="rect">
             <a:avLst/>
@@ -6515,8 +5968,44 @@
           </a:bodyPr>
           <a:lstStyle/>
           <a:p>
+            <a:pPr algn="ctr">
+              <a:defRPr sz="1500" b="1">
+                <a:solidFill>
+                  <a:srgbClr val="FFFFFF"/>
+                </a:solidFill>
+                <a:latin typeface="Arial"/>
+              </a:defRPr>
+            </a:pPr>
+            <a:r>
+              <a:t>1. Ổ đĩa gốc (Root)</a:t>
+            </a:r>
+          </a:p>
+        </p:txBody>
+      </p:sp>
+      <p:sp>
+        <p:nvSpPr>
+          <p:cNvPr id="9" name="TextBox 8"/>
+          <p:cNvSpPr txBox="1"/>
+          <p:nvPr/>
+        </p:nvSpPr>
+        <p:spPr>
+          <a:xfrm>
+            <a:off x="502920" y="2240280"/>
+            <a:ext cx="3291840" cy="594359"/>
+          </a:xfrm>
+          <a:prstGeom prst="rect">
+            <a:avLst/>
+          </a:prstGeom>
+          <a:noFill/>
+        </p:spPr>
+        <p:txBody>
+          <a:bodyPr wrap="square" lIns="73152" rIns="73152" tIns="54864" bIns="54864">
+            <a:spAutoFit/>
+          </a:bodyPr>
+          <a:lstStyle/>
+          <a:p>
             <a:pPr algn="l">
-              <a:defRPr sz="1500" b="1">
+              <a:defRPr sz="1400" b="0">
                 <a:solidFill>
                   <a:srgbClr val="0F172A"/>
                 </a:solidFill>
@@ -6524,21 +6013,21 @@
               </a:defRPr>
             </a:pPr>
             <a:r>
-              <a:t>• Ngăn trái: Sơ đồ cây các ổ đĩa và thư mục</a:t>
-            </a:r>
-          </a:p>
-        </p:txBody>
-      </p:sp>
-      <p:sp>
-        <p:nvSpPr>
-          <p:cNvPr id="9" name="TextBox 8"/>
+              <a:t>• Ổ đĩa C:, D:, E:</a:t>
+            </a:r>
+          </a:p>
+        </p:txBody>
+      </p:sp>
+      <p:sp>
+        <p:nvSpPr>
+          <p:cNvPr id="10" name="TextBox 9"/>
           <p:cNvSpPr txBox="1"/>
           <p:nvPr/>
         </p:nvSpPr>
         <p:spPr>
           <a:xfrm>
-            <a:off x="640080" y="2468880"/>
-            <a:ext cx="3429000" cy="640080"/>
+            <a:off x="502920" y="2880360"/>
+            <a:ext cx="3291840" cy="594359"/>
           </a:xfrm>
           <a:prstGeom prst="rect">
             <a:avLst/>
@@ -6552,7 +6041,7 @@
           <a:lstStyle/>
           <a:p>
             <a:pPr algn="l">
-              <a:defRPr sz="1500" b="1">
+              <a:defRPr sz="1400" b="0">
                 <a:solidFill>
                   <a:srgbClr val="0F172A"/>
                 </a:solidFill>
@@ -6560,21 +6049,109 @@
               </a:defRPr>
             </a:pPr>
             <a:r>
-              <a:t>• Ngăn phải: Nội dung chi tiết của thư mục đang chọn</a:t>
-            </a:r>
-          </a:p>
-        </p:txBody>
-      </p:sp>
-      <p:sp>
-        <p:nvSpPr>
-          <p:cNvPr id="10" name="TextBox 9"/>
+              <a:t>• Nơi chứa toàn bộ cây dữ liệu</a:t>
+            </a:r>
+          </a:p>
+        </p:txBody>
+      </p:sp>
+      <p:sp>
+        <p:nvSpPr>
+          <p:cNvPr id="11" name="Rounded Rectangle 10"/>
+          <p:cNvSpPr/>
+          <p:nvPr/>
+        </p:nvSpPr>
+        <p:spPr>
+          <a:xfrm>
+            <a:off x="4206240" y="1645920"/>
+            <a:ext cx="3566160" cy="3977639"/>
+          </a:xfrm>
+          <a:prstGeom prst="roundRect">
+            <a:avLst/>
+          </a:prstGeom>
+          <a:solidFill>
+            <a:srgbClr val="FFFFFF"/>
+          </a:solidFill>
+          <a:ln w="19050">
+            <a:solidFill>
+              <a:srgbClr val="0D9488"/>
+            </a:solidFill>
+          </a:ln>
+        </p:spPr>
+        <p:style>
+          <a:lnRef idx="1">
+            <a:schemeClr val="accent1"/>
+          </a:lnRef>
+          <a:fillRef idx="3">
+            <a:schemeClr val="accent1"/>
+          </a:fillRef>
+          <a:effectRef idx="2">
+            <a:schemeClr val="accent1"/>
+          </a:effectRef>
+          <a:fontRef idx="minor">
+            <a:schemeClr val="lt1"/>
+          </a:fontRef>
+        </p:style>
+        <p:txBody>
+          <a:bodyPr rtlCol="0" anchor="ctr"/>
+          <a:lstStyle/>
+          <a:p>
+            <a:pPr algn="ctr"/>
+          </a:p>
+        </p:txBody>
+      </p:sp>
+      <p:sp>
+        <p:nvSpPr>
+          <p:cNvPr id="12" name="Rounded Rectangle 11"/>
+          <p:cNvSpPr/>
+          <p:nvPr/>
+        </p:nvSpPr>
+        <p:spPr>
+          <a:xfrm>
+            <a:off x="4206240" y="1645920"/>
+            <a:ext cx="3566160" cy="457199"/>
+          </a:xfrm>
+          <a:prstGeom prst="roundRect">
+            <a:avLst/>
+          </a:prstGeom>
+          <a:solidFill>
+            <a:srgbClr val="0D9488"/>
+          </a:solidFill>
+          <a:ln>
+            <a:noFill/>
+          </a:ln>
+        </p:spPr>
+        <p:style>
+          <a:lnRef idx="1">
+            <a:schemeClr val="accent1"/>
+          </a:lnRef>
+          <a:fillRef idx="3">
+            <a:schemeClr val="accent1"/>
+          </a:fillRef>
+          <a:effectRef idx="2">
+            <a:schemeClr val="accent1"/>
+          </a:effectRef>
+          <a:fontRef idx="minor">
+            <a:schemeClr val="lt1"/>
+          </a:fontRef>
+        </p:style>
+        <p:txBody>
+          <a:bodyPr rtlCol="0" anchor="ctr"/>
+          <a:lstStyle/>
+          <a:p>
+            <a:pPr algn="ctr"/>
+          </a:p>
+        </p:txBody>
+      </p:sp>
+      <p:sp>
+        <p:nvSpPr>
+          <p:cNvPr id="13" name="TextBox 12"/>
           <p:cNvSpPr txBox="1"/>
           <p:nvPr/>
         </p:nvSpPr>
         <p:spPr>
           <a:xfrm>
-            <a:off x="640080" y="3154680"/>
-            <a:ext cx="3429000" cy="640080"/>
+            <a:off x="4206240" y="1691640"/>
+            <a:ext cx="3566160" cy="411480"/>
           </a:xfrm>
           <a:prstGeom prst="rect">
             <a:avLst/>
@@ -6587,8 +6164,44 @@
           </a:bodyPr>
           <a:lstStyle/>
           <a:p>
+            <a:pPr algn="ctr">
+              <a:defRPr sz="1500" b="1">
+                <a:solidFill>
+                  <a:srgbClr val="FFFFFF"/>
+                </a:solidFill>
+                <a:latin typeface="Arial"/>
+              </a:defRPr>
+            </a:pPr>
+            <a:r>
+              <a:t>2. Thư mục (Folder)</a:t>
+            </a:r>
+          </a:p>
+        </p:txBody>
+      </p:sp>
+      <p:sp>
+        <p:nvSpPr>
+          <p:cNvPr id="14" name="TextBox 13"/>
+          <p:cNvSpPr txBox="1"/>
+          <p:nvPr/>
+        </p:nvSpPr>
+        <p:spPr>
+          <a:xfrm>
+            <a:off x="4343400" y="2240280"/>
+            <a:ext cx="3291840" cy="594359"/>
+          </a:xfrm>
+          <a:prstGeom prst="rect">
+            <a:avLst/>
+          </a:prstGeom>
+          <a:noFill/>
+        </p:spPr>
+        <p:txBody>
+          <a:bodyPr wrap="square" lIns="73152" rIns="73152" tIns="54864" bIns="54864">
+            <a:spAutoFit/>
+          </a:bodyPr>
+          <a:lstStyle/>
+          <a:p>
             <a:pPr algn="l">
-              <a:defRPr sz="1500" b="1">
+              <a:defRPr sz="1400" b="0">
                 <a:solidFill>
                   <a:srgbClr val="0F172A"/>
                 </a:solidFill>
@@ -6596,21 +6209,21 @@
               </a:defRPr>
             </a:pPr>
             <a:r>
-              <a:t>• Đường dẫn (Path): Địa chỉ chính xác của tệp</a:t>
-            </a:r>
-          </a:p>
-        </p:txBody>
-      </p:sp>
-      <p:sp>
-        <p:nvSpPr>
-          <p:cNvPr id="11" name="TextBox 10"/>
+              <a:t>• Thư mục mẹ chứa thư mục con</a:t>
+            </a:r>
+          </a:p>
+        </p:txBody>
+      </p:sp>
+      <p:sp>
+        <p:nvSpPr>
+          <p:cNvPr id="15" name="TextBox 14"/>
           <p:cNvSpPr txBox="1"/>
           <p:nvPr/>
         </p:nvSpPr>
         <p:spPr>
           <a:xfrm>
-            <a:off x="640080" y="3840480"/>
-            <a:ext cx="3429000" cy="640080"/>
+            <a:off x="4343400" y="2880360"/>
+            <a:ext cx="3291840" cy="594359"/>
           </a:xfrm>
           <a:prstGeom prst="rect">
             <a:avLst/>
@@ -6624,7 +6237,7 @@
           <a:lstStyle/>
           <a:p>
             <a:pPr algn="l">
-              <a:defRPr sz="1500" b="1">
+              <a:defRPr sz="1400" b="0">
                 <a:solidFill>
                   <a:srgbClr val="0F172A"/>
                 </a:solidFill>
@@ -6632,21 +6245,21 @@
               </a:defRPr>
             </a:pPr>
             <a:r>
-              <a:t>• Thao tác nhanh: New folder, Rename, Delete</a:t>
-            </a:r>
-          </a:p>
-        </p:txBody>
-      </p:sp>
-      <p:sp>
-        <p:nvSpPr>
-          <p:cNvPr id="12" name="Rounded Rectangle 11"/>
+              <a:t>• Ví dụ: TOAN, VAN, TIN_HOC</a:t>
+            </a:r>
+          </a:p>
+        </p:txBody>
+      </p:sp>
+      <p:sp>
+        <p:nvSpPr>
+          <p:cNvPr id="16" name="Rounded Rectangle 15"/>
           <p:cNvSpPr/>
           <p:nvPr/>
         </p:nvSpPr>
         <p:spPr>
           <a:xfrm>
-            <a:off x="4480560" y="1645920"/>
-            <a:ext cx="7223760" cy="3977639"/>
+            <a:off x="8046720" y="1645920"/>
+            <a:ext cx="3566160" cy="3977639"/>
           </a:xfrm>
           <a:prstGeom prst="roundRect">
             <a:avLst/>
@@ -6656,7 +6269,7 @@
           </a:solidFill>
           <a:ln w="19050">
             <a:solidFill>
-              <a:srgbClr val="CBD5E1"/>
+              <a:srgbClr val="D97706"/>
             </a:solidFill>
           </a:ln>
         </p:spPr>
@@ -6682,30 +6295,157 @@
           </a:p>
         </p:txBody>
       </p:sp>
-      <p:pic>
-        <p:nvPicPr>
-          <p:cNvPr id="13" name="Picture 12" descr="sgk_lop5_bai4_file_explorer.png"/>
-          <p:cNvPicPr>
-            <a:picLocks noChangeAspect="1"/>
-          </p:cNvPicPr>
-          <p:nvPr/>
-        </p:nvPicPr>
-        <p:blipFill>
-          <a:blip r:embed="rId2"/>
-          <a:stretch>
-            <a:fillRect/>
-          </a:stretch>
-        </p:blipFill>
-        <p:spPr>
-          <a:xfrm>
-            <a:off x="4572000" y="1737360"/>
-            <a:ext cx="7040880" cy="3794760"/>
+      <p:sp>
+        <p:nvSpPr>
+          <p:cNvPr id="17" name="Rounded Rectangle 16"/>
+          <p:cNvSpPr/>
+          <p:nvPr/>
+        </p:nvSpPr>
+        <p:spPr>
+          <a:xfrm>
+            <a:off x="8046720" y="1645920"/>
+            <a:ext cx="3566160" cy="457199"/>
+          </a:xfrm>
+          <a:prstGeom prst="roundRect">
+            <a:avLst/>
+          </a:prstGeom>
+          <a:solidFill>
+            <a:srgbClr val="D97706"/>
+          </a:solidFill>
+          <a:ln>
+            <a:noFill/>
+          </a:ln>
+        </p:spPr>
+        <p:style>
+          <a:lnRef idx="1">
+            <a:schemeClr val="accent1"/>
+          </a:lnRef>
+          <a:fillRef idx="3">
+            <a:schemeClr val="accent1"/>
+          </a:fillRef>
+          <a:effectRef idx="2">
+            <a:schemeClr val="accent1"/>
+          </a:effectRef>
+          <a:fontRef idx="minor">
+            <a:schemeClr val="lt1"/>
+          </a:fontRef>
+        </p:style>
+        <p:txBody>
+          <a:bodyPr rtlCol="0" anchor="ctr"/>
+          <a:lstStyle/>
+          <a:p>
+            <a:pPr algn="ctr"/>
+          </a:p>
+        </p:txBody>
+      </p:sp>
+      <p:sp>
+        <p:nvSpPr>
+          <p:cNvPr id="18" name="TextBox 17"/>
+          <p:cNvSpPr txBox="1"/>
+          <p:nvPr/>
+        </p:nvSpPr>
+        <p:spPr>
+          <a:xfrm>
+            <a:off x="8046720" y="1691640"/>
+            <a:ext cx="3566160" cy="411480"/>
           </a:xfrm>
           <a:prstGeom prst="rect">
             <a:avLst/>
           </a:prstGeom>
-        </p:spPr>
-      </p:pic>
+          <a:noFill/>
+        </p:spPr>
+        <p:txBody>
+          <a:bodyPr wrap="square" lIns="73152" rIns="73152" tIns="54864" bIns="54864">
+            <a:spAutoFit/>
+          </a:bodyPr>
+          <a:lstStyle/>
+          <a:p>
+            <a:pPr algn="ctr">
+              <a:defRPr sz="1500" b="1">
+                <a:solidFill>
+                  <a:srgbClr val="FFFFFF"/>
+                </a:solidFill>
+                <a:latin typeface="Arial"/>
+              </a:defRPr>
+            </a:pPr>
+            <a:r>
+              <a:t>3. Tệp tin (File)</a:t>
+            </a:r>
+          </a:p>
+        </p:txBody>
+      </p:sp>
+      <p:sp>
+        <p:nvSpPr>
+          <p:cNvPr id="19" name="TextBox 18"/>
+          <p:cNvSpPr txBox="1"/>
+          <p:nvPr/>
+        </p:nvSpPr>
+        <p:spPr>
+          <a:xfrm>
+            <a:off x="8183880" y="2240280"/>
+            <a:ext cx="3291840" cy="594359"/>
+          </a:xfrm>
+          <a:prstGeom prst="rect">
+            <a:avLst/>
+          </a:prstGeom>
+          <a:noFill/>
+        </p:spPr>
+        <p:txBody>
+          <a:bodyPr wrap="square" lIns="73152" rIns="73152" tIns="54864" bIns="54864">
+            <a:spAutoFit/>
+          </a:bodyPr>
+          <a:lstStyle/>
+          <a:p>
+            <a:pPr algn="l">
+              <a:defRPr sz="1400" b="0">
+                <a:solidFill>
+                  <a:srgbClr val="0F172A"/>
+                </a:solidFill>
+                <a:latin typeface="Arial"/>
+              </a:defRPr>
+            </a:pPr>
+            <a:r>
+              <a:t>• Bài văn .docx, Bài giảng .pptx</a:t>
+            </a:r>
+          </a:p>
+        </p:txBody>
+      </p:sp>
+      <p:sp>
+        <p:nvSpPr>
+          <p:cNvPr id="20" name="TextBox 19"/>
+          <p:cNvSpPr txBox="1"/>
+          <p:nvPr/>
+        </p:nvSpPr>
+        <p:spPr>
+          <a:xfrm>
+            <a:off x="8183880" y="2880360"/>
+            <a:ext cx="3291840" cy="594359"/>
+          </a:xfrm>
+          <a:prstGeom prst="rect">
+            <a:avLst/>
+          </a:prstGeom>
+          <a:noFill/>
+        </p:spPr>
+        <p:txBody>
+          <a:bodyPr wrap="square" lIns="73152" rIns="73152" tIns="54864" bIns="54864">
+            <a:spAutoFit/>
+          </a:bodyPr>
+          <a:lstStyle/>
+          <a:p>
+            <a:pPr algn="l">
+              <a:defRPr sz="1400" b="0">
+                <a:solidFill>
+                  <a:srgbClr val="0F172A"/>
+                </a:solidFill>
+                <a:latin typeface="Arial"/>
+              </a:defRPr>
+            </a:pPr>
+            <a:r>
+              <a:t>• Tranh vẽ .png, Âm thanh .mp3</a:t>
+            </a:r>
+          </a:p>
+        </p:txBody>
+      </p:sp>
     </p:spTree>
   </p:cSld>
   <p:clrMapOvr>
@@ -6844,7 +6584,7 @@
               </a:defRPr>
             </a:pPr>
             <a:r>
-              <a:t>❓ Tổng kết: Kỹ năng trọng tâm của Tuần 04 là gì?</a:t>
+              <a:t>❓ Tổng kết kiến thức trọng tâm Tuần 04 (Lớp 5)</a:t>
             </a:r>
           </a:p>
         </p:txBody>
@@ -6968,7 +6708,7 @@
               </a:defRPr>
             </a:pPr>
             <a:r>
-              <a:t>👉 Tiết 3: Thu thập và tìm kiếm thông tin chính xác bằng từ khóa.</a:t>
+              <a:t>👉 Tiết 3: Thu thập và tìm kiếm thông tin chính xác bằng từ khóa " ".</a:t>
             </a:r>
           </a:p>
         </p:txBody>
@@ -7056,7 +6796,7 @@
       </p:sp>
       <p:pic>
         <p:nvPicPr>
-          <p:cNvPr id="10" name="Picture 9" descr="sgk_lop5_bai4_luyen_tap.png"/>
+          <p:cNvPr id="10" name="Picture 9" descr="ai_lop5_bai4_tree.jpg"/>
           <p:cNvPicPr>
             <a:picLocks noChangeAspect="1"/>
           </p:cNvPicPr>

</xml_diff>

<commit_message>
feat(slides): Chuan hoa 100% Khop noi Ngu nghia Hinh anh va Chu viet Tieng Viet trong Slide Tin hoc Lop 5 & 7
</commit_message>
<xml_diff>
--- a/KHBD_Tin_học/Lớp_5/Tuần_04/Slide_Tin_hoc_Lop_5_Bai03_04.pptx
+++ b/KHBD_Tin_học/Lớp_5/Tuần_04/Slide_Tin_hoc_Lop_5_Bai03_04.pptx
@@ -4707,7 +4707,7 @@
               </a:defRPr>
             </a:pPr>
             <a:r>
-              <a:t>HOẠT ĐỘNG KHÁM PHÁ</a:t>
+              <a:t>QUY TRÌNH &amp; THAO TÁC</a:t>
             </a:r>
           </a:p>
         </p:txBody>
@@ -4743,32 +4743,30 @@
               </a:defRPr>
             </a:pPr>
             <a:r>
-              <a:t>Kỹ thuật sử dụng Từ khóa tìm kiếm thần kỳ</a:t>
-            </a:r>
-          </a:p>
-        </p:txBody>
-      </p:sp>
-      <p:sp>
-        <p:nvSpPr>
-          <p:cNvPr id="6" name="Rounded Rectangle 5"/>
+              <a:t>Sơ đồ 4 bước tìm kiếm thông tin chính xác</a:t>
+            </a:r>
+          </a:p>
+        </p:txBody>
+      </p:sp>
+      <p:sp>
+        <p:nvSpPr>
+          <p:cNvPr id="6" name="Chevron 5"/>
           <p:cNvSpPr/>
           <p:nvPr/>
         </p:nvSpPr>
         <p:spPr>
           <a:xfrm>
             <a:off x="365760" y="1645920"/>
-            <a:ext cx="4023360" cy="3977639"/>
-          </a:xfrm>
-          <a:prstGeom prst="roundRect">
+            <a:ext cx="4389120" cy="868680"/>
+          </a:xfrm>
+          <a:prstGeom prst="chevron">
             <a:avLst/>
           </a:prstGeom>
           <a:solidFill>
-            <a:srgbClr val="FFFFFF"/>
+            <a:srgbClr val="BE185D"/>
           </a:solidFill>
-          <a:ln w="19050">
-            <a:solidFill>
-              <a:srgbClr val="EC4899"/>
-            </a:solidFill>
+          <a:ln>
+            <a:noFill/>
           </a:ln>
         </p:spPr>
         <p:style>
@@ -4795,16 +4793,52 @@
       </p:sp>
       <p:sp>
         <p:nvSpPr>
-          <p:cNvPr id="7" name="Rounded Rectangle 6"/>
+          <p:cNvPr id="7" name="TextBox 6"/>
+          <p:cNvSpPr txBox="1"/>
+          <p:nvPr/>
+        </p:nvSpPr>
+        <p:spPr>
+          <a:xfrm>
+            <a:off x="594360" y="1719072"/>
+            <a:ext cx="3840480" cy="731520"/>
+          </a:xfrm>
+          <a:prstGeom prst="rect">
+            <a:avLst/>
+          </a:prstGeom>
+          <a:noFill/>
+        </p:spPr>
+        <p:txBody>
+          <a:bodyPr wrap="square" lIns="73152" rIns="73152" tIns="54864" bIns="54864">
+            <a:spAutoFit/>
+          </a:bodyPr>
+          <a:lstStyle/>
+          <a:p>
+            <a:pPr algn="l">
+              <a:defRPr sz="1400" b="1">
+                <a:solidFill>
+                  <a:srgbClr val="FFFFFF"/>
+                </a:solidFill>
+                <a:latin typeface="Arial"/>
+              </a:defRPr>
+            </a:pPr>
+            <a:r>
+              <a:t>Bước 1: Xác định thông tin</a:t>
+            </a:r>
+          </a:p>
+        </p:txBody>
+      </p:sp>
+      <p:sp>
+        <p:nvSpPr>
+          <p:cNvPr id="8" name="Chevron 7"/>
           <p:cNvSpPr/>
           <p:nvPr/>
         </p:nvSpPr>
         <p:spPr>
           <a:xfrm>
-            <a:off x="365760" y="1645920"/>
-            <a:ext cx="164592" cy="3977639"/>
-          </a:xfrm>
-          <a:prstGeom prst="roundRect">
+            <a:off x="365760" y="2624328"/>
+            <a:ext cx="4389120" cy="868680"/>
+          </a:xfrm>
+          <a:prstGeom prst="chevron">
             <a:avLst/>
           </a:prstGeom>
           <a:solidFill>
@@ -4838,14 +4872,14 @@
       </p:sp>
       <p:sp>
         <p:nvSpPr>
-          <p:cNvPr id="8" name="TextBox 7"/>
+          <p:cNvPr id="9" name="TextBox 8"/>
           <p:cNvSpPr txBox="1"/>
           <p:nvPr/>
         </p:nvSpPr>
         <p:spPr>
           <a:xfrm>
-            <a:off x="640080" y="1783080"/>
-            <a:ext cx="3611880" cy="640080"/>
+            <a:off x="594360" y="2697480"/>
+            <a:ext cx="3840480" cy="731519"/>
           </a:xfrm>
           <a:prstGeom prst="rect">
             <a:avLst/>
@@ -4859,29 +4893,72 @@
           <a:lstStyle/>
           <a:p>
             <a:pPr algn="l">
-              <a:defRPr sz="1500" b="1">
+              <a:defRPr sz="1400" b="1">
                 <a:solidFill>
-                  <a:srgbClr val="0F172A"/>
+                  <a:srgbClr val="FFFFFF"/>
                 </a:solidFill>
                 <a:latin typeface="Arial"/>
               </a:defRPr>
             </a:pPr>
             <a:r>
-              <a:t>• Chọn từ khóa ngắn gọn, chính xác</a:t>
-            </a:r>
-          </a:p>
-        </p:txBody>
-      </p:sp>
-      <p:sp>
-        <p:nvSpPr>
-          <p:cNvPr id="9" name="TextBox 8"/>
+              <a:t>Bước 2: Chọn từ khóa " "</a:t>
+            </a:r>
+          </a:p>
+        </p:txBody>
+      </p:sp>
+      <p:sp>
+        <p:nvSpPr>
+          <p:cNvPr id="10" name="Chevron 9"/>
+          <p:cNvSpPr/>
+          <p:nvPr/>
+        </p:nvSpPr>
+        <p:spPr>
+          <a:xfrm>
+            <a:off x="365760" y="3602736"/>
+            <a:ext cx="4389120" cy="868679"/>
+          </a:xfrm>
+          <a:prstGeom prst="chevron">
+            <a:avLst/>
+          </a:prstGeom>
+          <a:solidFill>
+            <a:srgbClr val="0D9488"/>
+          </a:solidFill>
+          <a:ln>
+            <a:noFill/>
+          </a:ln>
+        </p:spPr>
+        <p:style>
+          <a:lnRef idx="1">
+            <a:schemeClr val="accent1"/>
+          </a:lnRef>
+          <a:fillRef idx="3">
+            <a:schemeClr val="accent1"/>
+          </a:fillRef>
+          <a:effectRef idx="2">
+            <a:schemeClr val="accent1"/>
+          </a:effectRef>
+          <a:fontRef idx="minor">
+            <a:schemeClr val="lt1"/>
+          </a:fontRef>
+        </p:style>
+        <p:txBody>
+          <a:bodyPr rtlCol="0" anchor="ctr"/>
+          <a:lstStyle/>
+          <a:p>
+            <a:pPr algn="ctr"/>
+          </a:p>
+        </p:txBody>
+      </p:sp>
+      <p:sp>
+        <p:nvSpPr>
+          <p:cNvPr id="11" name="TextBox 10"/>
           <p:cNvSpPr txBox="1"/>
           <p:nvPr/>
         </p:nvSpPr>
         <p:spPr>
           <a:xfrm>
-            <a:off x="640080" y="2468880"/>
-            <a:ext cx="3611880" cy="640080"/>
+            <a:off x="594360" y="3675887"/>
+            <a:ext cx="3840480" cy="731519"/>
           </a:xfrm>
           <a:prstGeom prst="rect">
             <a:avLst/>
@@ -4895,29 +4972,72 @@
           <a:lstStyle/>
           <a:p>
             <a:pPr algn="l">
-              <a:defRPr sz="1500" b="1">
+              <a:defRPr sz="1400" b="1">
                 <a:solidFill>
-                  <a:srgbClr val="0F172A"/>
+                  <a:srgbClr val="FFFFFF"/>
                 </a:solidFill>
                 <a:latin typeface="Arial"/>
               </a:defRPr>
             </a:pPr>
             <a:r>
-              <a:t>• Đặt từ khóa trong dấu ngoặc kép " "</a:t>
-            </a:r>
-          </a:p>
-        </p:txBody>
-      </p:sp>
-      <p:sp>
-        <p:nvSpPr>
-          <p:cNvPr id="10" name="TextBox 9"/>
+              <a:t>Bước 3: Chọn nguồn uy tín</a:t>
+            </a:r>
+          </a:p>
+        </p:txBody>
+      </p:sp>
+      <p:sp>
+        <p:nvSpPr>
+          <p:cNvPr id="12" name="Chevron 11"/>
+          <p:cNvSpPr/>
+          <p:nvPr/>
+        </p:nvSpPr>
+        <p:spPr>
+          <a:xfrm>
+            <a:off x="365760" y="4581144"/>
+            <a:ext cx="4389120" cy="868680"/>
+          </a:xfrm>
+          <a:prstGeom prst="chevron">
+            <a:avLst/>
+          </a:prstGeom>
+          <a:solidFill>
+            <a:srgbClr val="D97706"/>
+          </a:solidFill>
+          <a:ln>
+            <a:noFill/>
+          </a:ln>
+        </p:spPr>
+        <p:style>
+          <a:lnRef idx="1">
+            <a:schemeClr val="accent1"/>
+          </a:lnRef>
+          <a:fillRef idx="3">
+            <a:schemeClr val="accent1"/>
+          </a:fillRef>
+          <a:effectRef idx="2">
+            <a:schemeClr val="accent1"/>
+          </a:effectRef>
+          <a:fontRef idx="minor">
+            <a:schemeClr val="lt1"/>
+          </a:fontRef>
+        </p:style>
+        <p:txBody>
+          <a:bodyPr rtlCol="0" anchor="ctr"/>
+          <a:lstStyle/>
+          <a:p>
+            <a:pPr algn="ctr"/>
+          </a:p>
+        </p:txBody>
+      </p:sp>
+      <p:sp>
+        <p:nvSpPr>
+          <p:cNvPr id="13" name="TextBox 12"/>
           <p:cNvSpPr txBox="1"/>
           <p:nvPr/>
         </p:nvSpPr>
         <p:spPr>
           <a:xfrm>
-            <a:off x="640080" y="3154680"/>
-            <a:ext cx="3611880" cy="640080"/>
+            <a:off x="594360" y="4654296"/>
+            <a:ext cx="3840480" cy="731519"/>
           </a:xfrm>
           <a:prstGeom prst="rect">
             <a:avLst/>
@@ -4931,65 +5051,29 @@
           <a:lstStyle/>
           <a:p>
             <a:pPr algn="l">
-              <a:defRPr sz="1500" b="1">
+              <a:defRPr sz="1400" b="1">
                 <a:solidFill>
-                  <a:srgbClr val="0F172A"/>
+                  <a:srgbClr val="FFFFFF"/>
                 </a:solidFill>
                 <a:latin typeface="Arial"/>
               </a:defRPr>
             </a:pPr>
             <a:r>
-              <a:t>• Ưu tiên nguồn tin chính thống, đáng tin cậy</a:t>
-            </a:r>
-          </a:p>
-        </p:txBody>
-      </p:sp>
-      <p:sp>
-        <p:nvSpPr>
-          <p:cNvPr id="11" name="TextBox 10"/>
-          <p:cNvSpPr txBox="1"/>
-          <p:nvPr/>
-        </p:nvSpPr>
-        <p:spPr>
-          <a:xfrm>
-            <a:off x="640080" y="3840480"/>
-            <a:ext cx="3611880" cy="640080"/>
-          </a:xfrm>
-          <a:prstGeom prst="rect">
-            <a:avLst/>
-          </a:prstGeom>
-          <a:noFill/>
-        </p:spPr>
-        <p:txBody>
-          <a:bodyPr wrap="square" lIns="73152" rIns="73152" tIns="54864" bIns="54864">
-            <a:spAutoFit/>
-          </a:bodyPr>
-          <a:lstStyle/>
-          <a:p>
-            <a:pPr algn="l">
-              <a:defRPr sz="1500" b="1">
-                <a:solidFill>
-                  <a:srgbClr val="0F172A"/>
-                </a:solidFill>
-                <a:latin typeface="Arial"/>
-              </a:defRPr>
-            </a:pPr>
-            <a:r>
-              <a:t>• Giải quyết vấn đề nhanh chóng và hiệu quả</a:t>
-            </a:r>
-          </a:p>
-        </p:txBody>
-      </p:sp>
-      <p:sp>
-        <p:nvSpPr>
-          <p:cNvPr id="12" name="Rounded Rectangle 11"/>
+              <a:t>Bước 4: Tổng hợp &amp; áp dụng</a:t>
+            </a:r>
+          </a:p>
+        </p:txBody>
+      </p:sp>
+      <p:sp>
+        <p:nvSpPr>
+          <p:cNvPr id="14" name="Rounded Rectangle 13"/>
           <p:cNvSpPr/>
           <p:nvPr/>
         </p:nvSpPr>
         <p:spPr>
           <a:xfrm>
-            <a:off x="4663440" y="1645920"/>
-            <a:ext cx="7040880" cy="3977639"/>
+            <a:off x="5029200" y="1645920"/>
+            <a:ext cx="6675120" cy="3977639"/>
           </a:xfrm>
           <a:prstGeom prst="roundRect">
             <a:avLst/>
@@ -5027,7 +5111,7 @@
       </p:sp>
       <p:pic>
         <p:nvPicPr>
-          <p:cNvPr id="13" name="Picture 12" descr="ai_lop5_bai3_search.jpg"/>
+          <p:cNvPr id="15" name="Picture 14" descr="lop5_bai3_quy_trinh_tim_kiem_4buoc.png"/>
           <p:cNvPicPr>
             <a:picLocks noChangeAspect="1"/>
           </p:cNvPicPr>
@@ -5041,8 +5125,8 @@
         </p:blipFill>
         <p:spPr>
           <a:xfrm>
-            <a:off x="4754880" y="1737360"/>
-            <a:ext cx="6858000" cy="3794760"/>
+            <a:off x="5120640" y="1737360"/>
+            <a:ext cx="6492240" cy="3794760"/>
           </a:xfrm>
           <a:prstGeom prst="rect">
             <a:avLst/>
@@ -5445,7 +5529,7 @@
               </a:defRPr>
             </a:pPr>
             <a:r>
-              <a:t>KHỞI ĐỘNG &amp; TÌNH HUỐNG</a:t>
+              <a:t>QUY TRÌNH &amp; THAO TÁC</a:t>
             </a:r>
           </a:p>
         </p:txBody>
@@ -5481,21 +5565,337 @@
               </a:defRPr>
             </a:pPr>
             <a:r>
-              <a:t>Cây tri thức — Sơ đồ Cây thư mục kỳ diệu</a:t>
-            </a:r>
-          </a:p>
-        </p:txBody>
-      </p:sp>
-      <p:sp>
-        <p:nvSpPr>
-          <p:cNvPr id="6" name="Rounded Rectangle 5"/>
+              <a:t>4 Thao tác quản lý thư mục cơ bản</a:t>
+            </a:r>
+          </a:p>
+        </p:txBody>
+      </p:sp>
+      <p:sp>
+        <p:nvSpPr>
+          <p:cNvPr id="6" name="Chevron 5"/>
           <p:cNvSpPr/>
           <p:nvPr/>
         </p:nvSpPr>
         <p:spPr>
           <a:xfrm>
             <a:off x="365760" y="1645920"/>
-            <a:ext cx="11247120" cy="2971800"/>
+            <a:ext cx="4389120" cy="868680"/>
+          </a:xfrm>
+          <a:prstGeom prst="chevron">
+            <a:avLst/>
+          </a:prstGeom>
+          <a:solidFill>
+            <a:srgbClr val="BE185D"/>
+          </a:solidFill>
+          <a:ln>
+            <a:noFill/>
+          </a:ln>
+        </p:spPr>
+        <p:style>
+          <a:lnRef idx="1">
+            <a:schemeClr val="accent1"/>
+          </a:lnRef>
+          <a:fillRef idx="3">
+            <a:schemeClr val="accent1"/>
+          </a:fillRef>
+          <a:effectRef idx="2">
+            <a:schemeClr val="accent1"/>
+          </a:effectRef>
+          <a:fontRef idx="minor">
+            <a:schemeClr val="lt1"/>
+          </a:fontRef>
+        </p:style>
+        <p:txBody>
+          <a:bodyPr rtlCol="0" anchor="ctr"/>
+          <a:lstStyle/>
+          <a:p>
+            <a:pPr algn="ctr"/>
+          </a:p>
+        </p:txBody>
+      </p:sp>
+      <p:sp>
+        <p:nvSpPr>
+          <p:cNvPr id="7" name="TextBox 6"/>
+          <p:cNvSpPr txBox="1"/>
+          <p:nvPr/>
+        </p:nvSpPr>
+        <p:spPr>
+          <a:xfrm>
+            <a:off x="594360" y="1719072"/>
+            <a:ext cx="3840480" cy="731520"/>
+          </a:xfrm>
+          <a:prstGeom prst="rect">
+            <a:avLst/>
+          </a:prstGeom>
+          <a:noFill/>
+        </p:spPr>
+        <p:txBody>
+          <a:bodyPr wrap="square" lIns="73152" rIns="73152" tIns="54864" bIns="54864">
+            <a:spAutoFit/>
+          </a:bodyPr>
+          <a:lstStyle/>
+          <a:p>
+            <a:pPr algn="l">
+              <a:defRPr sz="1400" b="1">
+                <a:solidFill>
+                  <a:srgbClr val="FFFFFF"/>
+                </a:solidFill>
+                <a:latin typeface="Arial"/>
+              </a:defRPr>
+            </a:pPr>
+            <a:r>
+              <a:t>1. Tạo thư mục mới (New)</a:t>
+            </a:r>
+          </a:p>
+        </p:txBody>
+      </p:sp>
+      <p:sp>
+        <p:nvSpPr>
+          <p:cNvPr id="8" name="Chevron 7"/>
+          <p:cNvSpPr/>
+          <p:nvPr/>
+        </p:nvSpPr>
+        <p:spPr>
+          <a:xfrm>
+            <a:off x="365760" y="2624328"/>
+            <a:ext cx="4389120" cy="868680"/>
+          </a:xfrm>
+          <a:prstGeom prst="chevron">
+            <a:avLst/>
+          </a:prstGeom>
+          <a:solidFill>
+            <a:srgbClr val="EC4899"/>
+          </a:solidFill>
+          <a:ln>
+            <a:noFill/>
+          </a:ln>
+        </p:spPr>
+        <p:style>
+          <a:lnRef idx="1">
+            <a:schemeClr val="accent1"/>
+          </a:lnRef>
+          <a:fillRef idx="3">
+            <a:schemeClr val="accent1"/>
+          </a:fillRef>
+          <a:effectRef idx="2">
+            <a:schemeClr val="accent1"/>
+          </a:effectRef>
+          <a:fontRef idx="minor">
+            <a:schemeClr val="lt1"/>
+          </a:fontRef>
+        </p:style>
+        <p:txBody>
+          <a:bodyPr rtlCol="0" anchor="ctr"/>
+          <a:lstStyle/>
+          <a:p>
+            <a:pPr algn="ctr"/>
+          </a:p>
+        </p:txBody>
+      </p:sp>
+      <p:sp>
+        <p:nvSpPr>
+          <p:cNvPr id="9" name="TextBox 8"/>
+          <p:cNvSpPr txBox="1"/>
+          <p:nvPr/>
+        </p:nvSpPr>
+        <p:spPr>
+          <a:xfrm>
+            <a:off x="594360" y="2697480"/>
+            <a:ext cx="3840480" cy="731519"/>
+          </a:xfrm>
+          <a:prstGeom prst="rect">
+            <a:avLst/>
+          </a:prstGeom>
+          <a:noFill/>
+        </p:spPr>
+        <p:txBody>
+          <a:bodyPr wrap="square" lIns="73152" rIns="73152" tIns="54864" bIns="54864">
+            <a:spAutoFit/>
+          </a:bodyPr>
+          <a:lstStyle/>
+          <a:p>
+            <a:pPr algn="l">
+              <a:defRPr sz="1400" b="1">
+                <a:solidFill>
+                  <a:srgbClr val="FFFFFF"/>
+                </a:solidFill>
+                <a:latin typeface="Arial"/>
+              </a:defRPr>
+            </a:pPr>
+            <a:r>
+              <a:t>2. Đổi tên thư mục (Rename)</a:t>
+            </a:r>
+          </a:p>
+        </p:txBody>
+      </p:sp>
+      <p:sp>
+        <p:nvSpPr>
+          <p:cNvPr id="10" name="Chevron 9"/>
+          <p:cNvSpPr/>
+          <p:nvPr/>
+        </p:nvSpPr>
+        <p:spPr>
+          <a:xfrm>
+            <a:off x="365760" y="3602736"/>
+            <a:ext cx="4389120" cy="868679"/>
+          </a:xfrm>
+          <a:prstGeom prst="chevron">
+            <a:avLst/>
+          </a:prstGeom>
+          <a:solidFill>
+            <a:srgbClr val="0D9488"/>
+          </a:solidFill>
+          <a:ln>
+            <a:noFill/>
+          </a:ln>
+        </p:spPr>
+        <p:style>
+          <a:lnRef idx="1">
+            <a:schemeClr val="accent1"/>
+          </a:lnRef>
+          <a:fillRef idx="3">
+            <a:schemeClr val="accent1"/>
+          </a:fillRef>
+          <a:effectRef idx="2">
+            <a:schemeClr val="accent1"/>
+          </a:effectRef>
+          <a:fontRef idx="minor">
+            <a:schemeClr val="lt1"/>
+          </a:fontRef>
+        </p:style>
+        <p:txBody>
+          <a:bodyPr rtlCol="0" anchor="ctr"/>
+          <a:lstStyle/>
+          <a:p>
+            <a:pPr algn="ctr"/>
+          </a:p>
+        </p:txBody>
+      </p:sp>
+      <p:sp>
+        <p:nvSpPr>
+          <p:cNvPr id="11" name="TextBox 10"/>
+          <p:cNvSpPr txBox="1"/>
+          <p:nvPr/>
+        </p:nvSpPr>
+        <p:spPr>
+          <a:xfrm>
+            <a:off x="594360" y="3675887"/>
+            <a:ext cx="3840480" cy="731519"/>
+          </a:xfrm>
+          <a:prstGeom prst="rect">
+            <a:avLst/>
+          </a:prstGeom>
+          <a:noFill/>
+        </p:spPr>
+        <p:txBody>
+          <a:bodyPr wrap="square" lIns="73152" rIns="73152" tIns="54864" bIns="54864">
+            <a:spAutoFit/>
+          </a:bodyPr>
+          <a:lstStyle/>
+          <a:p>
+            <a:pPr algn="l">
+              <a:defRPr sz="1400" b="1">
+                <a:solidFill>
+                  <a:srgbClr val="FFFFFF"/>
+                </a:solidFill>
+                <a:latin typeface="Arial"/>
+              </a:defRPr>
+            </a:pPr>
+            <a:r>
+              <a:t>3. Sao chép / Cắt &amp; Dán</a:t>
+            </a:r>
+          </a:p>
+        </p:txBody>
+      </p:sp>
+      <p:sp>
+        <p:nvSpPr>
+          <p:cNvPr id="12" name="Chevron 11"/>
+          <p:cNvSpPr/>
+          <p:nvPr/>
+        </p:nvSpPr>
+        <p:spPr>
+          <a:xfrm>
+            <a:off x="365760" y="4581144"/>
+            <a:ext cx="4389120" cy="868680"/>
+          </a:xfrm>
+          <a:prstGeom prst="chevron">
+            <a:avLst/>
+          </a:prstGeom>
+          <a:solidFill>
+            <a:srgbClr val="D97706"/>
+          </a:solidFill>
+          <a:ln>
+            <a:noFill/>
+          </a:ln>
+        </p:spPr>
+        <p:style>
+          <a:lnRef idx="1">
+            <a:schemeClr val="accent1"/>
+          </a:lnRef>
+          <a:fillRef idx="3">
+            <a:schemeClr val="accent1"/>
+          </a:fillRef>
+          <a:effectRef idx="2">
+            <a:schemeClr val="accent1"/>
+          </a:effectRef>
+          <a:fontRef idx="minor">
+            <a:schemeClr val="lt1"/>
+          </a:fontRef>
+        </p:style>
+        <p:txBody>
+          <a:bodyPr rtlCol="0" anchor="ctr"/>
+          <a:lstStyle/>
+          <a:p>
+            <a:pPr algn="ctr"/>
+          </a:p>
+        </p:txBody>
+      </p:sp>
+      <p:sp>
+        <p:nvSpPr>
+          <p:cNvPr id="13" name="TextBox 12"/>
+          <p:cNvSpPr txBox="1"/>
+          <p:nvPr/>
+        </p:nvSpPr>
+        <p:spPr>
+          <a:xfrm>
+            <a:off x="594360" y="4654296"/>
+            <a:ext cx="3840480" cy="731519"/>
+          </a:xfrm>
+          <a:prstGeom prst="rect">
+            <a:avLst/>
+          </a:prstGeom>
+          <a:noFill/>
+        </p:spPr>
+        <p:txBody>
+          <a:bodyPr wrap="square" lIns="73152" rIns="73152" tIns="54864" bIns="54864">
+            <a:spAutoFit/>
+          </a:bodyPr>
+          <a:lstStyle/>
+          <a:p>
+            <a:pPr algn="l">
+              <a:defRPr sz="1400" b="1">
+                <a:solidFill>
+                  <a:srgbClr val="FFFFFF"/>
+                </a:solidFill>
+                <a:latin typeface="Arial"/>
+              </a:defRPr>
+            </a:pPr>
+            <a:r>
+              <a:t>4. Xóa thư mục rác (Delete)</a:t>
+            </a:r>
+          </a:p>
+        </p:txBody>
+      </p:sp>
+      <p:sp>
+        <p:nvSpPr>
+          <p:cNvPr id="14" name="Rounded Rectangle 13"/>
+          <p:cNvSpPr/>
+          <p:nvPr/>
+        </p:nvSpPr>
+        <p:spPr>
+          <a:xfrm>
+            <a:off x="5029200" y="1645920"/>
+            <a:ext cx="6675120" cy="3977639"/>
           </a:xfrm>
           <a:prstGeom prst="roundRect">
             <a:avLst/>
@@ -5505,7 +5905,7 @@
           </a:solidFill>
           <a:ln w="19050">
             <a:solidFill>
-              <a:srgbClr val="EC4899"/>
+              <a:srgbClr val="CBD5E1"/>
             </a:solidFill>
           </a:ln>
         </p:spPr>
@@ -5533,7 +5933,7 @@
       </p:sp>
       <p:pic>
         <p:nvPicPr>
-          <p:cNvPr id="7" name="Picture 6" descr="ai_lop5_bai4_tree.jpg"/>
+          <p:cNvPr id="15" name="Picture 14" descr="lop5_bai4_4_operations_flow.png"/>
           <p:cNvPicPr>
             <a:picLocks noChangeAspect="1"/>
           </p:cNvPicPr>
@@ -5547,138 +5947,14 @@
         </p:blipFill>
         <p:spPr>
           <a:xfrm>
-            <a:off x="457200" y="1691640"/>
-            <a:ext cx="11064240" cy="2880360"/>
+            <a:off x="5120640" y="1737360"/>
+            <a:ext cx="6492240" cy="3794760"/>
           </a:xfrm>
           <a:prstGeom prst="rect">
             <a:avLst/>
           </a:prstGeom>
         </p:spPr>
       </p:pic>
-      <p:sp>
-        <p:nvSpPr>
-          <p:cNvPr id="8" name="Rounded Rectangle 7"/>
-          <p:cNvSpPr/>
-          <p:nvPr/>
-        </p:nvSpPr>
-        <p:spPr>
-          <a:xfrm>
-            <a:off x="365760" y="4709160"/>
-            <a:ext cx="11247120" cy="960119"/>
-          </a:xfrm>
-          <a:prstGeom prst="roundRect">
-            <a:avLst/>
-          </a:prstGeom>
-          <a:solidFill>
-            <a:srgbClr val="FFFFFF"/>
-          </a:solidFill>
-          <a:ln w="19050">
-            <a:solidFill>
-              <a:srgbClr val="BE185D"/>
-            </a:solidFill>
-          </a:ln>
-        </p:spPr>
-        <p:style>
-          <a:lnRef idx="1">
-            <a:schemeClr val="accent1"/>
-          </a:lnRef>
-          <a:fillRef idx="3">
-            <a:schemeClr val="accent1"/>
-          </a:fillRef>
-          <a:effectRef idx="2">
-            <a:schemeClr val="accent1"/>
-          </a:effectRef>
-          <a:fontRef idx="minor">
-            <a:schemeClr val="lt1"/>
-          </a:fontRef>
-        </p:style>
-        <p:txBody>
-          <a:bodyPr rtlCol="0" anchor="ctr"/>
-          <a:lstStyle/>
-          <a:p>
-            <a:pPr algn="ctr"/>
-          </a:p>
-        </p:txBody>
-      </p:sp>
-      <p:sp>
-        <p:nvSpPr>
-          <p:cNvPr id="9" name="Rounded Rectangle 8"/>
-          <p:cNvSpPr/>
-          <p:nvPr/>
-        </p:nvSpPr>
-        <p:spPr>
-          <a:xfrm>
-            <a:off x="365760" y="4709160"/>
-            <a:ext cx="182880" cy="960119"/>
-          </a:xfrm>
-          <a:prstGeom prst="roundRect">
-            <a:avLst/>
-          </a:prstGeom>
-          <a:solidFill>
-            <a:srgbClr val="BE185D"/>
-          </a:solidFill>
-          <a:ln>
-            <a:noFill/>
-          </a:ln>
-        </p:spPr>
-        <p:style>
-          <a:lnRef idx="1">
-            <a:schemeClr val="accent1"/>
-          </a:lnRef>
-          <a:fillRef idx="3">
-            <a:schemeClr val="accent1"/>
-          </a:fillRef>
-          <a:effectRef idx="2">
-            <a:schemeClr val="accent1"/>
-          </a:effectRef>
-          <a:fontRef idx="minor">
-            <a:schemeClr val="lt1"/>
-          </a:fontRef>
-        </p:style>
-        <p:txBody>
-          <a:bodyPr rtlCol="0" anchor="ctr"/>
-          <a:lstStyle/>
-          <a:p>
-            <a:pPr algn="ctr"/>
-          </a:p>
-        </p:txBody>
-      </p:sp>
-      <p:sp>
-        <p:nvSpPr>
-          <p:cNvPr id="10" name="TextBox 9"/>
-          <p:cNvSpPr txBox="1"/>
-          <p:nvPr/>
-        </p:nvSpPr>
-        <p:spPr>
-          <a:xfrm>
-            <a:off x="685800" y="4800600"/>
-            <a:ext cx="10607040" cy="777239"/>
-          </a:xfrm>
-          <a:prstGeom prst="rect">
-            <a:avLst/>
-          </a:prstGeom>
-          <a:noFill/>
-        </p:spPr>
-        <p:txBody>
-          <a:bodyPr wrap="square" lIns="73152" rIns="73152" tIns="54864" bIns="54864">
-            <a:spAutoFit/>
-          </a:bodyPr>
-          <a:lstStyle/>
-          <a:p>
-            <a:pPr algn="l">
-              <a:defRPr sz="1500" b="1">
-                <a:solidFill>
-                  <a:srgbClr val="0F172A"/>
-                </a:solidFill>
-                <a:latin typeface="Arial"/>
-              </a:defRPr>
-            </a:pPr>
-            <a:r>
-              <a:t>👉 Gốc là ổ đĩa (C:, D:), Cành lớn là Thư mục mẹ, Cành nhỏ là Thư mục con, Quả là các Tệp tin!</a:t>
-            </a:r>
-          </a:p>
-        </p:txBody>
-      </p:sp>
     </p:spTree>
   </p:cSld>
   <p:clrMapOvr>
@@ -5817,7 +6093,7 @@
               </a:defRPr>
             </a:pPr>
             <a:r>
-              <a:t>KIẾN THỨC CỐT LÕI</a:t>
+              <a:t>HOẠT ĐỘNG KHÁM PHÁ</a:t>
             </a:r>
           </a:p>
         </p:txBody>
@@ -5853,7 +6129,7 @@
               </a:defRPr>
             </a:pPr>
             <a:r>
-              <a:t>Các thành phần trong Cây thư mục</a:t>
+              <a:t>Thực hành xây dựng Cây thư mục học tập</a:t>
             </a:r>
           </a:p>
         </p:txBody>
@@ -5867,7 +6143,7 @@
         <p:spPr>
           <a:xfrm>
             <a:off x="365760" y="1645920"/>
-            <a:ext cx="3566160" cy="3977639"/>
+            <a:ext cx="4023360" cy="3977639"/>
           </a:xfrm>
           <a:prstGeom prst="roundRect">
             <a:avLst/>
@@ -5877,7 +6153,7 @@
           </a:solidFill>
           <a:ln w="19050">
             <a:solidFill>
-              <a:srgbClr val="BE185D"/>
+              <a:srgbClr val="EC4899"/>
             </a:solidFill>
           </a:ln>
         </p:spPr>
@@ -5912,13 +6188,13 @@
         <p:spPr>
           <a:xfrm>
             <a:off x="365760" y="1645920"/>
-            <a:ext cx="3566160" cy="457199"/>
+            <a:ext cx="164592" cy="3977639"/>
           </a:xfrm>
           <a:prstGeom prst="roundRect">
             <a:avLst/>
           </a:prstGeom>
           <a:solidFill>
-            <a:srgbClr val="BE185D"/>
+            <a:srgbClr val="EC4899"/>
           </a:solidFill>
           <a:ln>
             <a:noFill/>
@@ -5954,8 +6230,8 @@
         </p:nvSpPr>
         <p:spPr>
           <a:xfrm>
-            <a:off x="365760" y="1691640"/>
-            <a:ext cx="3566160" cy="411480"/>
+            <a:off x="640080" y="1783080"/>
+            <a:ext cx="3611880" cy="640080"/>
           </a:xfrm>
           <a:prstGeom prst="rect">
             <a:avLst/>
@@ -5968,44 +6244,8 @@
           </a:bodyPr>
           <a:lstStyle/>
           <a:p>
-            <a:pPr algn="ctr">
+            <a:pPr algn="l">
               <a:defRPr sz="1500" b="1">
-                <a:solidFill>
-                  <a:srgbClr val="FFFFFF"/>
-                </a:solidFill>
-                <a:latin typeface="Arial"/>
-              </a:defRPr>
-            </a:pPr>
-            <a:r>
-              <a:t>1. Ổ đĩa gốc (Root)</a:t>
-            </a:r>
-          </a:p>
-        </p:txBody>
-      </p:sp>
-      <p:sp>
-        <p:nvSpPr>
-          <p:cNvPr id="9" name="TextBox 8"/>
-          <p:cNvSpPr txBox="1"/>
-          <p:nvPr/>
-        </p:nvSpPr>
-        <p:spPr>
-          <a:xfrm>
-            <a:off x="502920" y="2240280"/>
-            <a:ext cx="3291840" cy="594359"/>
-          </a:xfrm>
-          <a:prstGeom prst="rect">
-            <a:avLst/>
-          </a:prstGeom>
-          <a:noFill/>
-        </p:spPr>
-        <p:txBody>
-          <a:bodyPr wrap="square" lIns="73152" rIns="73152" tIns="54864" bIns="54864">
-            <a:spAutoFit/>
-          </a:bodyPr>
-          <a:lstStyle/>
-          <a:p>
-            <a:pPr algn="l">
-              <a:defRPr sz="1400" b="0">
                 <a:solidFill>
                   <a:srgbClr val="0F172A"/>
                 </a:solidFill>
@@ -6013,21 +6253,21 @@
               </a:defRPr>
             </a:pPr>
             <a:r>
-              <a:t>• Ổ đĩa C:, D:, E:</a:t>
-            </a:r>
-          </a:p>
-        </p:txBody>
-      </p:sp>
-      <p:sp>
-        <p:nvSpPr>
-          <p:cNvPr id="10" name="TextBox 9"/>
+              <a:t>• Tạo thư mục mẹ HOC_TAP trên ổ đĩa D:</a:t>
+            </a:r>
+          </a:p>
+        </p:txBody>
+      </p:sp>
+      <p:sp>
+        <p:nvSpPr>
+          <p:cNvPr id="9" name="TextBox 8"/>
           <p:cNvSpPr txBox="1"/>
           <p:nvPr/>
         </p:nvSpPr>
         <p:spPr>
           <a:xfrm>
-            <a:off x="502920" y="2880360"/>
-            <a:ext cx="3291840" cy="594359"/>
+            <a:off x="640080" y="2468880"/>
+            <a:ext cx="3611880" cy="640080"/>
           </a:xfrm>
           <a:prstGeom prst="rect">
             <a:avLst/>
@@ -6041,7 +6281,7 @@
           <a:lstStyle/>
           <a:p>
             <a:pPr algn="l">
-              <a:defRPr sz="1400" b="0">
+              <a:defRPr sz="1500" b="1">
                 <a:solidFill>
                   <a:srgbClr val="0F172A"/>
                 </a:solidFill>
@@ -6049,109 +6289,21 @@
               </a:defRPr>
             </a:pPr>
             <a:r>
-              <a:t>• Nơi chứa toàn bộ cây dữ liệu</a:t>
-            </a:r>
-          </a:p>
-        </p:txBody>
-      </p:sp>
-      <p:sp>
-        <p:nvSpPr>
-          <p:cNvPr id="11" name="Rounded Rectangle 10"/>
-          <p:cNvSpPr/>
-          <p:nvPr/>
-        </p:nvSpPr>
-        <p:spPr>
-          <a:xfrm>
-            <a:off x="4206240" y="1645920"/>
-            <a:ext cx="3566160" cy="3977639"/>
-          </a:xfrm>
-          <a:prstGeom prst="roundRect">
-            <a:avLst/>
-          </a:prstGeom>
-          <a:solidFill>
-            <a:srgbClr val="FFFFFF"/>
-          </a:solidFill>
-          <a:ln w="19050">
-            <a:solidFill>
-              <a:srgbClr val="0D9488"/>
-            </a:solidFill>
-          </a:ln>
-        </p:spPr>
-        <p:style>
-          <a:lnRef idx="1">
-            <a:schemeClr val="accent1"/>
-          </a:lnRef>
-          <a:fillRef idx="3">
-            <a:schemeClr val="accent1"/>
-          </a:fillRef>
-          <a:effectRef idx="2">
-            <a:schemeClr val="accent1"/>
-          </a:effectRef>
-          <a:fontRef idx="minor">
-            <a:schemeClr val="lt1"/>
-          </a:fontRef>
-        </p:style>
-        <p:txBody>
-          <a:bodyPr rtlCol="0" anchor="ctr"/>
-          <a:lstStyle/>
-          <a:p>
-            <a:pPr algn="ctr"/>
-          </a:p>
-        </p:txBody>
-      </p:sp>
-      <p:sp>
-        <p:nvSpPr>
-          <p:cNvPr id="12" name="Rounded Rectangle 11"/>
-          <p:cNvSpPr/>
-          <p:nvPr/>
-        </p:nvSpPr>
-        <p:spPr>
-          <a:xfrm>
-            <a:off x="4206240" y="1645920"/>
-            <a:ext cx="3566160" cy="457199"/>
-          </a:xfrm>
-          <a:prstGeom prst="roundRect">
-            <a:avLst/>
-          </a:prstGeom>
-          <a:solidFill>
-            <a:srgbClr val="0D9488"/>
-          </a:solidFill>
-          <a:ln>
-            <a:noFill/>
-          </a:ln>
-        </p:spPr>
-        <p:style>
-          <a:lnRef idx="1">
-            <a:schemeClr val="accent1"/>
-          </a:lnRef>
-          <a:fillRef idx="3">
-            <a:schemeClr val="accent1"/>
-          </a:fillRef>
-          <a:effectRef idx="2">
-            <a:schemeClr val="accent1"/>
-          </a:effectRef>
-          <a:fontRef idx="minor">
-            <a:schemeClr val="lt1"/>
-          </a:fontRef>
-        </p:style>
-        <p:txBody>
-          <a:bodyPr rtlCol="0" anchor="ctr"/>
-          <a:lstStyle/>
-          <a:p>
-            <a:pPr algn="ctr"/>
-          </a:p>
-        </p:txBody>
-      </p:sp>
-      <p:sp>
-        <p:nvSpPr>
-          <p:cNvPr id="13" name="TextBox 12"/>
+              <a:t>• Tạo 3 thư mục con: TOAN, TIENG_VIET, TIN_HOC</a:t>
+            </a:r>
+          </a:p>
+        </p:txBody>
+      </p:sp>
+      <p:sp>
+        <p:nvSpPr>
+          <p:cNvPr id="10" name="TextBox 9"/>
           <p:cNvSpPr txBox="1"/>
           <p:nvPr/>
         </p:nvSpPr>
         <p:spPr>
           <a:xfrm>
-            <a:off x="4206240" y="1691640"/>
-            <a:ext cx="3566160" cy="411480"/>
+            <a:off x="640080" y="3154680"/>
+            <a:ext cx="3611880" cy="640080"/>
           </a:xfrm>
           <a:prstGeom prst="rect">
             <a:avLst/>
@@ -6164,44 +6316,8 @@
           </a:bodyPr>
           <a:lstStyle/>
           <a:p>
-            <a:pPr algn="ctr">
+            <a:pPr algn="l">
               <a:defRPr sz="1500" b="1">
-                <a:solidFill>
-                  <a:srgbClr val="FFFFFF"/>
-                </a:solidFill>
-                <a:latin typeface="Arial"/>
-              </a:defRPr>
-            </a:pPr>
-            <a:r>
-              <a:t>2. Thư mục (Folder)</a:t>
-            </a:r>
-          </a:p>
-        </p:txBody>
-      </p:sp>
-      <p:sp>
-        <p:nvSpPr>
-          <p:cNvPr id="14" name="TextBox 13"/>
-          <p:cNvSpPr txBox="1"/>
-          <p:nvPr/>
-        </p:nvSpPr>
-        <p:spPr>
-          <a:xfrm>
-            <a:off x="4343400" y="2240280"/>
-            <a:ext cx="3291840" cy="594359"/>
-          </a:xfrm>
-          <a:prstGeom prst="rect">
-            <a:avLst/>
-          </a:prstGeom>
-          <a:noFill/>
-        </p:spPr>
-        <p:txBody>
-          <a:bodyPr wrap="square" lIns="73152" rIns="73152" tIns="54864" bIns="54864">
-            <a:spAutoFit/>
-          </a:bodyPr>
-          <a:lstStyle/>
-          <a:p>
-            <a:pPr algn="l">
-              <a:defRPr sz="1400" b="0">
                 <a:solidFill>
                   <a:srgbClr val="0F172A"/>
                 </a:solidFill>
@@ -6209,21 +6325,21 @@
               </a:defRPr>
             </a:pPr>
             <a:r>
-              <a:t>• Thư mục mẹ chứa thư mục con</a:t>
-            </a:r>
-          </a:p>
-        </p:txBody>
-      </p:sp>
-      <p:sp>
-        <p:nvSpPr>
-          <p:cNvPr id="15" name="TextBox 14"/>
+              <a:t>• Lưu bài tập vào đúng thư mục tương ứng</a:t>
+            </a:r>
+          </a:p>
+        </p:txBody>
+      </p:sp>
+      <p:sp>
+        <p:nvSpPr>
+          <p:cNvPr id="11" name="TextBox 10"/>
           <p:cNvSpPr txBox="1"/>
           <p:nvPr/>
         </p:nvSpPr>
         <p:spPr>
           <a:xfrm>
-            <a:off x="4343400" y="2880360"/>
-            <a:ext cx="3291840" cy="594359"/>
+            <a:off x="640080" y="3840480"/>
+            <a:ext cx="3611880" cy="640080"/>
           </a:xfrm>
           <a:prstGeom prst="rect">
             <a:avLst/>
@@ -6237,7 +6353,7 @@
           <a:lstStyle/>
           <a:p>
             <a:pPr algn="l">
-              <a:defRPr sz="1400" b="0">
+              <a:defRPr sz="1500" b="1">
                 <a:solidFill>
                   <a:srgbClr val="0F172A"/>
                 </a:solidFill>
@@ -6245,21 +6361,21 @@
               </a:defRPr>
             </a:pPr>
             <a:r>
-              <a:t>• Ví dụ: TOAN, VAN, TIN_HOC</a:t>
-            </a:r>
-          </a:p>
-        </p:txBody>
-      </p:sp>
-      <p:sp>
-        <p:nvSpPr>
-          <p:cNvPr id="16" name="Rounded Rectangle 15"/>
+              <a:t>• Cấu trúc chuẩn Tiếng Việt rõ ràng, ngăn nắp!</a:t>
+            </a:r>
+          </a:p>
+        </p:txBody>
+      </p:sp>
+      <p:sp>
+        <p:nvSpPr>
+          <p:cNvPr id="12" name="Rounded Rectangle 11"/>
           <p:cNvSpPr/>
           <p:nvPr/>
         </p:nvSpPr>
         <p:spPr>
           <a:xfrm>
-            <a:off x="8046720" y="1645920"/>
-            <a:ext cx="3566160" cy="3977639"/>
+            <a:off x="4663440" y="1645920"/>
+            <a:ext cx="7040880" cy="3977639"/>
           </a:xfrm>
           <a:prstGeom prst="roundRect">
             <a:avLst/>
@@ -6269,7 +6385,7 @@
           </a:solidFill>
           <a:ln w="19050">
             <a:solidFill>
-              <a:srgbClr val="D97706"/>
+              <a:srgbClr val="CBD5E1"/>
             </a:solidFill>
           </a:ln>
         </p:spPr>
@@ -6295,157 +6411,30 @@
           </a:p>
         </p:txBody>
       </p:sp>
-      <p:sp>
-        <p:nvSpPr>
-          <p:cNvPr id="17" name="Rounded Rectangle 16"/>
-          <p:cNvSpPr/>
-          <p:nvPr/>
-        </p:nvSpPr>
-        <p:spPr>
-          <a:xfrm>
-            <a:off x="8046720" y="1645920"/>
-            <a:ext cx="3566160" cy="457199"/>
-          </a:xfrm>
-          <a:prstGeom prst="roundRect">
-            <a:avLst/>
-          </a:prstGeom>
-          <a:solidFill>
-            <a:srgbClr val="D97706"/>
-          </a:solidFill>
-          <a:ln>
-            <a:noFill/>
-          </a:ln>
-        </p:spPr>
-        <p:style>
-          <a:lnRef idx="1">
-            <a:schemeClr val="accent1"/>
-          </a:lnRef>
-          <a:fillRef idx="3">
-            <a:schemeClr val="accent1"/>
-          </a:fillRef>
-          <a:effectRef idx="2">
-            <a:schemeClr val="accent1"/>
-          </a:effectRef>
-          <a:fontRef idx="minor">
-            <a:schemeClr val="lt1"/>
-          </a:fontRef>
-        </p:style>
-        <p:txBody>
-          <a:bodyPr rtlCol="0" anchor="ctr"/>
-          <a:lstStyle/>
-          <a:p>
-            <a:pPr algn="ctr"/>
-          </a:p>
-        </p:txBody>
-      </p:sp>
-      <p:sp>
-        <p:nvSpPr>
-          <p:cNvPr id="18" name="TextBox 17"/>
-          <p:cNvSpPr txBox="1"/>
-          <p:nvPr/>
-        </p:nvSpPr>
-        <p:spPr>
-          <a:xfrm>
-            <a:off x="8046720" y="1691640"/>
-            <a:ext cx="3566160" cy="411480"/>
+      <p:pic>
+        <p:nvPicPr>
+          <p:cNvPr id="13" name="Picture 12" descr="lop5_bai4_cay_thuc_hanh_hoctap.png"/>
+          <p:cNvPicPr>
+            <a:picLocks noChangeAspect="1"/>
+          </p:cNvPicPr>
+          <p:nvPr/>
+        </p:nvPicPr>
+        <p:blipFill>
+          <a:blip r:embed="rId2"/>
+          <a:stretch>
+            <a:fillRect/>
+          </a:stretch>
+        </p:blipFill>
+        <p:spPr>
+          <a:xfrm>
+            <a:off x="4754880" y="1737360"/>
+            <a:ext cx="6858000" cy="3794760"/>
           </a:xfrm>
           <a:prstGeom prst="rect">
             <a:avLst/>
           </a:prstGeom>
-          <a:noFill/>
-        </p:spPr>
-        <p:txBody>
-          <a:bodyPr wrap="square" lIns="73152" rIns="73152" tIns="54864" bIns="54864">
-            <a:spAutoFit/>
-          </a:bodyPr>
-          <a:lstStyle/>
-          <a:p>
-            <a:pPr algn="ctr">
-              <a:defRPr sz="1500" b="1">
-                <a:solidFill>
-                  <a:srgbClr val="FFFFFF"/>
-                </a:solidFill>
-                <a:latin typeface="Arial"/>
-              </a:defRPr>
-            </a:pPr>
-            <a:r>
-              <a:t>3. Tệp tin (File)</a:t>
-            </a:r>
-          </a:p>
-        </p:txBody>
-      </p:sp>
-      <p:sp>
-        <p:nvSpPr>
-          <p:cNvPr id="19" name="TextBox 18"/>
-          <p:cNvSpPr txBox="1"/>
-          <p:nvPr/>
-        </p:nvSpPr>
-        <p:spPr>
-          <a:xfrm>
-            <a:off x="8183880" y="2240280"/>
-            <a:ext cx="3291840" cy="594359"/>
-          </a:xfrm>
-          <a:prstGeom prst="rect">
-            <a:avLst/>
-          </a:prstGeom>
-          <a:noFill/>
-        </p:spPr>
-        <p:txBody>
-          <a:bodyPr wrap="square" lIns="73152" rIns="73152" tIns="54864" bIns="54864">
-            <a:spAutoFit/>
-          </a:bodyPr>
-          <a:lstStyle/>
-          <a:p>
-            <a:pPr algn="l">
-              <a:defRPr sz="1400" b="0">
-                <a:solidFill>
-                  <a:srgbClr val="0F172A"/>
-                </a:solidFill>
-                <a:latin typeface="Arial"/>
-              </a:defRPr>
-            </a:pPr>
-            <a:r>
-              <a:t>• Bài văn .docx, Bài giảng .pptx</a:t>
-            </a:r>
-          </a:p>
-        </p:txBody>
-      </p:sp>
-      <p:sp>
-        <p:nvSpPr>
-          <p:cNvPr id="20" name="TextBox 19"/>
-          <p:cNvSpPr txBox="1"/>
-          <p:nvPr/>
-        </p:nvSpPr>
-        <p:spPr>
-          <a:xfrm>
-            <a:off x="8183880" y="2880360"/>
-            <a:ext cx="3291840" cy="594359"/>
-          </a:xfrm>
-          <a:prstGeom prst="rect">
-            <a:avLst/>
-          </a:prstGeom>
-          <a:noFill/>
-        </p:spPr>
-        <p:txBody>
-          <a:bodyPr wrap="square" lIns="73152" rIns="73152" tIns="54864" bIns="54864">
-            <a:spAutoFit/>
-          </a:bodyPr>
-          <a:lstStyle/>
-          <a:p>
-            <a:pPr algn="l">
-              <a:defRPr sz="1400" b="0">
-                <a:solidFill>
-                  <a:srgbClr val="0F172A"/>
-                </a:solidFill>
-                <a:latin typeface="Arial"/>
-              </a:defRPr>
-            </a:pPr>
-            <a:r>
-              <a:t>• Tranh vẽ .png, Âm thanh .mp3</a:t>
-            </a:r>
-          </a:p>
-        </p:txBody>
-      </p:sp>
+        </p:spPr>
+      </p:pic>
     </p:spTree>
   </p:cSld>
   <p:clrMapOvr>
@@ -6796,7 +6785,7 @@
       </p:sp>
       <p:pic>
         <p:nvPicPr>
-          <p:cNvPr id="10" name="Picture 9" descr="ai_lop5_bai4_tree.jpg"/>
+          <p:cNvPr id="10" name="Picture 9" descr="lop5_bai4_cay_thuc_hanh_hoctap.png"/>
           <p:cNvPicPr>
             <a:picLocks noChangeAspect="1"/>
           </p:cNvPicPr>

</xml_diff>

<commit_message>
feat(slides): Tich hop tranh AI 3D mo ta truc quan sinh dong tung quy trinh va vi du trong Slide Tin hoc Lop 5 & 7
</commit_message>
<xml_diff>
--- a/KHBD_Tin_học/Lớp_5/Tuần_04/Slide_Tin_hoc_Lop_5_Bai03_04.pptx
+++ b/KHBD_Tin_học/Lớp_5/Tuần_04/Slide_Tin_hoc_Lop_5_Bai03_04.pptx
@@ -4743,7 +4743,7 @@
               </a:defRPr>
             </a:pPr>
             <a:r>
-              <a:t>Sơ đồ 4 bước tìm kiếm thông tin chính xác</a:t>
+              <a:t>Quy trình 4 bước tìm kiếm thông tin chính xác</a:t>
             </a:r>
           </a:p>
         </p:txBody>
@@ -5111,7 +5111,7 @@
       </p:sp>
       <p:pic>
         <p:nvPicPr>
-          <p:cNvPr id="15" name="Picture 14" descr="lop5_bai3_quy_trinh_tim_kiem_4buoc.png"/>
+          <p:cNvPr id="15" name="Picture 14" descr="ai_lop5_bai3_search_flow.jpg"/>
           <p:cNvPicPr>
             <a:picLocks noChangeAspect="1"/>
           </p:cNvPicPr>
@@ -5933,7 +5933,7 @@
       </p:sp>
       <p:pic>
         <p:nvPicPr>
-          <p:cNvPr id="15" name="Picture 14" descr="lop5_bai4_4_operations_flow.png"/>
+          <p:cNvPr id="15" name="Picture 14" descr="ai_lop5_bai4_4steps_flow.jpg"/>
           <p:cNvPicPr>
             <a:picLocks noChangeAspect="1"/>
           </p:cNvPicPr>
@@ -6413,7 +6413,7 @@
       </p:sp>
       <p:pic>
         <p:nvPicPr>
-          <p:cNvPr id="13" name="Picture 12" descr="lop5_bai4_cay_thuc_hanh_hoctap.png"/>
+          <p:cNvPr id="13" name="Picture 12" descr="ai_lop5_bai4_hoctap_folders.jpg"/>
           <p:cNvPicPr>
             <a:picLocks noChangeAspect="1"/>
           </p:cNvPicPr>
@@ -6785,7 +6785,7 @@
       </p:sp>
       <p:pic>
         <p:nvPicPr>
-          <p:cNvPr id="10" name="Picture 9" descr="lop5_bai4_cay_thuc_hanh_hoctap.png"/>
+          <p:cNvPr id="10" name="Picture 9" descr="ai_lop5_bai4_hoctap_folders.jpg"/>
           <p:cNvPicPr>
             <a:picLocks noChangeAspect="1"/>
           </p:cNvPicPr>

</xml_diff>